<commit_message>
Add full narration to FHL showcase
Co-authored-by: Copilot <223556219+Copilot@users.noreply.github.com>

Copilot-Session: 0f63ea4f-a16b-4fa3-b141-785aec89b5e4
</commit_message>
<xml_diff>
--- a/FHL-Accessibility-Tree-Diff.pptx
+++ b/FHL-Accessibility-Tree-Diff.pptx
@@ -514,7 +514,7 @@
           <a:p>
             <a:r>
               <a:rPr lang="en-US" dirty="0"/>
-              <a:t/>
+              <a:t>Welcome to our FHL project showcase. We built Accessibility Tree Snapshot and Diff for React Native Windows. Its purpose is simple: catch accessibility regressions that visual review cannot see, and catch them before they ship. During FHL, we took this from an idea to a tested, hardened, working developer tool, with a real React Native Gallery demonstration.</a:t>
             </a:r>
             <a:endParaRPr lang="en-US" dirty="0"/>
           </a:p>
@@ -602,7 +602,7 @@
           <a:p>
             <a:r>
               <a:rPr lang="en-US" dirty="0"/>
-              <a:t/>
+              <a:t>The overall impact is to shift accessibility into normal engineering review. Today, visual review may pass, manual validation happens later, and engineers then reconstruct the cause from a bug. With this project, a baseline travels with the scenario, the diff exposes the semantic change, continuous integration can block the regression, and reviewers receive exact evidence. That means faster diagnosis, safer framework evolution, and fewer customer-found issues.</a:t>
             </a:r>
             <a:endParaRPr lang="en-US" dirty="0"/>
           </a:p>
@@ -690,7 +690,7 @@
           <a:p>
             <a:r>
               <a:rPr lang="en-US" dirty="0"/>
-              <a:t/>
+              <a:t>Assuming merge, the tool lives under packages, at RNW Scripts, Accessibility Diagnostics. Engineers run it through the existing Yarn workspace command. The current FHL implementation is available on the accessibility tree diff branch at commit 6909efe740. Its README documents target selection, capture limits, report formats, exit codes, privacy guidance, and incomplete snapshot behavior.</a:t>
             </a:r>
             <a:endParaRPr lang="en-US" dirty="0"/>
           </a:p>
@@ -778,7 +778,7 @@
           <a:p>
             <a:r>
               <a:rPr lang="en-US" dirty="0"/>
-              <a:t/>
+              <a:t>The architecture deliberately supports follow-on projects. The most compelling extension is a Focus Path Recorder that flags loops, unexpected jumps, unnamed targets, and offscreen focus. Other next steps include automated pull request comments, approved RNTester and Gallery baseline catalogs, an interactive tree explorer, component-specific rules, and comparison matrices across architectures, releases, and Windows versions.</a:t>
             </a:r>
             <a:endParaRPr lang="en-US" dirty="0"/>
           </a:p>
@@ -866,7 +866,7 @@
           <a:p>
             <a:r>
               <a:rPr lang="en-US" dirty="0"/>
-              <a:t/>
+              <a:t>Accessibility should not depend on someone noticing what cannot be seen. This project makes hidden semantic regressions visible, reviewable, and enforceable. Capture the tree. Compare the change. Catch the regression. Block it before merge. That is how we shift accessibility left. Thank you.</a:t>
             </a:r>
             <a:endParaRPr lang="en-US" dirty="0"/>
           </a:p>
@@ -954,7 +954,7 @@
           <a:p>
             <a:r>
               <a:rPr lang="en-US" dirty="0"/>
-              <a:t/>
+              <a:t>Here is the core problem. These two Gallery builds look identical. A screenshot comparison would pass, and a visual reviewer would see no change. But in the build on the right, Item 3 can no longer receive keyboard focus. For keyboard and screen reader users, that is a real product regression. Today, failures like this are often discovered only during late manual validation.</a:t>
             </a:r>
             <a:endParaRPr lang="en-US" dirty="0"/>
           </a:p>
@@ -1042,7 +1042,7 @@
           <a:p>
             <a:r>
               <a:rPr lang="en-US" dirty="0"/>
-              <a:t/>
+              <a:t>The project acts as a before-and-after detector for what assistive technology sees. It captures the Windows UI Automation tree, removes volatile and sensitive properties, matches stable elements, classifies meaningful changes, and produces console, JSON, or Markdown evidence. It is external and read-only, so existing applications need no instrumentation and RNW runtime behavior is not modified.</a:t>
             </a:r>
             <a:endParaRPr lang="en-US" dirty="0"/>
           </a:p>
@@ -1130,7 +1130,7 @@
           <a:p>
             <a:r>
               <a:rPr lang="en-US" dirty="0"/>
-              <a:t/>
+              <a:t>The workflow is intentionally small. First, capture a known-good application tree. Second, capture the application after the code change. Third, diff both snapshots and ask the tool to fail on potential regressions. Exit code one makes the result directly usable in continuous integration. This turns accessibility from an assumption into an artifact that reviewers can inspect and automation can enforce.</a:t>
             </a:r>
             <a:endParaRPr lang="en-US" dirty="0"/>
           </a:p>
@@ -1218,7 +1218,7 @@
           <a:p>
             <a:r>
               <a:rPr lang="en-US" dirty="0"/>
-              <a:t/>
+              <a:t>This is most valuable where implementation changes can alter semantics without changing pixels. Examples include Fabric migrations, native component refactors, accessibility bug fixes, dependency upgrades, and release validation. It can also become a pull request quality gate that catches removed controls, lost accessible names, changed roles, reordered elements, or controls that silently lose keyboard focusability.</a:t>
             </a:r>
             <a:endParaRPr lang="en-US" dirty="0"/>
           </a:p>
@@ -1306,7 +1306,7 @@
           <a:p>
             <a:r>
               <a:rPr lang="en-US" dirty="0"/>
-              <a:t/>
+              <a:t>A useful diff must be trustworthy. The collector traverses incrementally and enforces node and depth limits before expanding the tree. Matching stays within an already matched parent to avoid cascading false differences. Incomplete captures are explicit and rejected by default. The schema is deterministic, privacy-sensitive values are excluded, and externally supplied text is sanitized before console or Markdown rendering. Fifteen tests and live Windows validation cover the risky paths.</a:t>
             </a:r>
             <a:endParaRPr lang="en-US" dirty="0"/>
           </a:p>
@@ -1394,7 +1394,7 @@
           <a:p>
             <a:r>
               <a:rPr lang="en-US" dirty="0"/>
-              <a:t/>
+              <a:t>Play the embedded narrated Gallery demonstration. It shows the healthy baseline, the visually identical regression, the five issues detected by the tool, and the CI-blocking exit code.</a:t>
             </a:r>
             <a:endParaRPr lang="en-US" dirty="0"/>
           </a:p>
@@ -1482,7 +1482,7 @@
           <a:p>
             <a:r>
               <a:rPr lang="en-US" dirty="0"/>
-              <a:t/>
+              <a:t>The demonstration proves the key claim. The healthy and broken Gallery screenshots remain visually identical. A single shared renderer change makes Item 3 unfocusable in five different FlatList examples. The tool finds all five changes, classifies each one as a potential regression, and returns exit code one. This is precisely the type of failure that is easy to miss in review but expensive to discover after integration.</a:t>
             </a:r>
             <a:endParaRPr lang="en-US" dirty="0"/>
           </a:p>
@@ -1570,7 +1570,7 @@
           <a:p>
             <a:r>
               <a:rPr lang="en-US" dirty="0"/>
-              <a:t/>
+              <a:t>This is a working implementation rather than a design mockup. The package has fifteen automated tests, a warning-free release build, and live capture and diff validation against Windows applications. In the Gallery scenario it catches five propagated regressions from one source change. Because the tool is standalone and read-only, it provides immediate value with low risk to RNW product behavior.</a:t>
             </a:r>
             <a:endParaRPr lang="en-US" dirty="0"/>
           </a:p>
@@ -2369,6 +2369,39 @@
           </a:p>
         </p:txBody>
       </p:sp>
+      <p:pic>
+        <p:nvPicPr>
+          <p:cNvPr id="3" name="Media 0">
+            <a:hlinkClick r:id="" action="ppaction://media"/>
+          </p:cNvPr>
+          <p:cNvPicPr>
+            <a:picLocks noChangeAspect="1"/>
+          </p:cNvPicPr>
+          <p:nvPr>
+            <a:videoFile r:link="rId1"/>
+            <p:extLst>
+              <p:ext uri="{DAA4B4D4-6D71-4841-9C94-3DE7FCFB9230}">
+                <p14:media xmlns:p14="http://schemas.microsoft.com/office/powerpoint/2010/main" r:embed="rId2"/>
+              </p:ext>
+            </p:extLst>
+          </p:nvPr>
+        </p:nvPicPr>
+        <p:blipFill>
+          <a:blip r:embed="rId3"/>
+          <a:stretch>
+            <a:fillRect/>
+          </a:stretch>
+        </p:blipFill>
+        <p:spPr>
+          <a:xfrm>
+            <a:off x="11475720" y="164592"/>
+            <a:ext cx="384048" cy="384048"/>
+          </a:xfrm>
+          <a:prstGeom prst="rect">
+            <a:avLst/>
+          </a:prstGeom>
+        </p:spPr>
+      </p:pic>
     </p:spTree>
   </p:cSld>
   <p:clrMapOvr>
@@ -3407,6 +3440,39 @@
           </a:p>
         </p:txBody>
       </p:sp>
+      <p:pic>
+        <p:nvPicPr>
+          <p:cNvPr id="3" name="Media 0">
+            <a:hlinkClick r:id="" action="ppaction://media"/>
+          </p:cNvPr>
+          <p:cNvPicPr>
+            <a:picLocks noChangeAspect="1"/>
+          </p:cNvPicPr>
+          <p:nvPr>
+            <a:videoFile r:link="rId1"/>
+            <p:extLst>
+              <p:ext uri="{DAA4B4D4-6D71-4841-9C94-3DE7FCFB9230}">
+                <p14:media xmlns:p14="http://schemas.microsoft.com/office/powerpoint/2010/main" r:embed="rId2"/>
+              </p:ext>
+            </p:extLst>
+          </p:nvPr>
+        </p:nvPicPr>
+        <p:blipFill>
+          <a:blip r:embed="rId3"/>
+          <a:stretch>
+            <a:fillRect/>
+          </a:stretch>
+        </p:blipFill>
+        <p:spPr>
+          <a:xfrm>
+            <a:off x="11475720" y="164592"/>
+            <a:ext cx="384048" cy="384048"/>
+          </a:xfrm>
+          <a:prstGeom prst="rect">
+            <a:avLst/>
+          </a:prstGeom>
+        </p:spPr>
+      </p:pic>
       <p:sp>
         <p:nvSpPr>
           <p:cNvPr id="25" name="Slide Number Placeholder 0"/>
@@ -4127,6 +4193,39 @@
           </a:p>
         </p:txBody>
       </p:sp>
+      <p:pic>
+        <p:nvPicPr>
+          <p:cNvPr id="5" name="Media 0">
+            <a:hlinkClick r:id="" action="ppaction://media"/>
+          </p:cNvPr>
+          <p:cNvPicPr>
+            <a:picLocks noChangeAspect="1"/>
+          </p:cNvPicPr>
+          <p:nvPr>
+            <a:videoFile r:link="rId3"/>
+            <p:extLst>
+              <p:ext uri="{DAA4B4D4-6D71-4841-9C94-3DE7FCFB9230}">
+                <p14:media xmlns:p14="http://schemas.microsoft.com/office/powerpoint/2010/main" r:embed="rId4"/>
+              </p:ext>
+            </p:extLst>
+          </p:nvPr>
+        </p:nvPicPr>
+        <p:blipFill>
+          <a:blip r:embed="rId5"/>
+          <a:stretch>
+            <a:fillRect/>
+          </a:stretch>
+        </p:blipFill>
+        <p:spPr>
+          <a:xfrm>
+            <a:off x="11475720" y="164592"/>
+            <a:ext cx="384048" cy="384048"/>
+          </a:xfrm>
+          <a:prstGeom prst="rect">
+            <a:avLst/>
+          </a:prstGeom>
+        </p:spPr>
+      </p:pic>
       <p:sp>
         <p:nvSpPr>
           <p:cNvPr id="25" name="Slide Number Placeholder 0"/>
@@ -5243,6 +5342,39 @@
           </a:p>
         </p:txBody>
       </p:sp>
+      <p:pic>
+        <p:nvPicPr>
+          <p:cNvPr id="3" name="Media 0">
+            <a:hlinkClick r:id="" action="ppaction://media"/>
+          </p:cNvPr>
+          <p:cNvPicPr>
+            <a:picLocks noChangeAspect="1"/>
+          </p:cNvPicPr>
+          <p:nvPr>
+            <a:videoFile r:link="rId1"/>
+            <p:extLst>
+              <p:ext uri="{DAA4B4D4-6D71-4841-9C94-3DE7FCFB9230}">
+                <p14:media xmlns:p14="http://schemas.microsoft.com/office/powerpoint/2010/main" r:embed="rId2"/>
+              </p:ext>
+            </p:extLst>
+          </p:nvPr>
+        </p:nvPicPr>
+        <p:blipFill>
+          <a:blip r:embed="rId3"/>
+          <a:stretch>
+            <a:fillRect/>
+          </a:stretch>
+        </p:blipFill>
+        <p:spPr>
+          <a:xfrm>
+            <a:off x="11475720" y="164592"/>
+            <a:ext cx="384048" cy="384048"/>
+          </a:xfrm>
+          <a:prstGeom prst="rect">
+            <a:avLst/>
+          </a:prstGeom>
+        </p:spPr>
+      </p:pic>
       <p:sp>
         <p:nvSpPr>
           <p:cNvPr id="25" name="Slide Number Placeholder 0"/>
@@ -5517,6 +5649,39 @@
           </a:p>
         </p:txBody>
       </p:sp>
+      <p:pic>
+        <p:nvPicPr>
+          <p:cNvPr id="4" name="Media 0">
+            <a:hlinkClick r:id="" action="ppaction://media"/>
+          </p:cNvPr>
+          <p:cNvPicPr>
+            <a:picLocks noChangeAspect="1"/>
+          </p:cNvPicPr>
+          <p:nvPr>
+            <a:videoFile r:link="rId2"/>
+            <p:extLst>
+              <p:ext uri="{DAA4B4D4-6D71-4841-9C94-3DE7FCFB9230}">
+                <p14:media xmlns:p14="http://schemas.microsoft.com/office/powerpoint/2010/main" r:embed="rId3"/>
+              </p:ext>
+            </p:extLst>
+          </p:nvPr>
+        </p:nvPicPr>
+        <p:blipFill>
+          <a:blip r:embed="rId4"/>
+          <a:stretch>
+            <a:fillRect/>
+          </a:stretch>
+        </p:blipFill>
+        <p:spPr>
+          <a:xfrm>
+            <a:off x="11475720" y="164592"/>
+            <a:ext cx="384048" cy="384048"/>
+          </a:xfrm>
+          <a:prstGeom prst="rect">
+            <a:avLst/>
+          </a:prstGeom>
+        </p:spPr>
+      </p:pic>
     </p:spTree>
   </p:cSld>
   <p:clrMapOvr>
@@ -5952,6 +6117,39 @@
           </a:p>
         </p:txBody>
       </p:sp>
+      <p:pic>
+        <p:nvPicPr>
+          <p:cNvPr id="5" name="Media 0">
+            <a:hlinkClick r:id="" action="ppaction://media"/>
+          </p:cNvPr>
+          <p:cNvPicPr>
+            <a:picLocks noChangeAspect="1"/>
+          </p:cNvPicPr>
+          <p:nvPr>
+            <a:videoFile r:link="rId3"/>
+            <p:extLst>
+              <p:ext uri="{DAA4B4D4-6D71-4841-9C94-3DE7FCFB9230}">
+                <p14:media xmlns:p14="http://schemas.microsoft.com/office/powerpoint/2010/main" r:embed="rId4"/>
+              </p:ext>
+            </p:extLst>
+          </p:nvPr>
+        </p:nvPicPr>
+        <p:blipFill>
+          <a:blip r:embed="rId5"/>
+          <a:stretch>
+            <a:fillRect/>
+          </a:stretch>
+        </p:blipFill>
+        <p:spPr>
+          <a:xfrm>
+            <a:off x="11475720" y="164592"/>
+            <a:ext cx="384048" cy="384048"/>
+          </a:xfrm>
+          <a:prstGeom prst="rect">
+            <a:avLst/>
+          </a:prstGeom>
+        </p:spPr>
+      </p:pic>
       <p:sp>
         <p:nvSpPr>
           <p:cNvPr id="25" name="Slide Number Placeholder 0"/>
@@ -6339,6 +6537,39 @@
           </a:p>
         </p:txBody>
       </p:sp>
+      <p:pic>
+        <p:nvPicPr>
+          <p:cNvPr id="4" name="Media 0">
+            <a:hlinkClick r:id="" action="ppaction://media"/>
+          </p:cNvPr>
+          <p:cNvPicPr>
+            <a:picLocks noChangeAspect="1"/>
+          </p:cNvPicPr>
+          <p:nvPr>
+            <a:videoFile r:link="rId2"/>
+            <p:extLst>
+              <p:ext uri="{DAA4B4D4-6D71-4841-9C94-3DE7FCFB9230}">
+                <p14:media xmlns:p14="http://schemas.microsoft.com/office/powerpoint/2010/main" r:embed="rId3"/>
+              </p:ext>
+            </p:extLst>
+          </p:nvPr>
+        </p:nvPicPr>
+        <p:blipFill>
+          <a:blip r:embed="rId4"/>
+          <a:stretch>
+            <a:fillRect/>
+          </a:stretch>
+        </p:blipFill>
+        <p:spPr>
+          <a:xfrm>
+            <a:off x="11475720" y="164592"/>
+            <a:ext cx="384048" cy="384048"/>
+          </a:xfrm>
+          <a:prstGeom prst="rect">
+            <a:avLst/>
+          </a:prstGeom>
+        </p:spPr>
+      </p:pic>
       <p:sp>
         <p:nvSpPr>
           <p:cNvPr id="25" name="Slide Number Placeholder 0"/>
@@ -7164,6 +7395,39 @@
           </a:p>
         </p:txBody>
       </p:sp>
+      <p:pic>
+        <p:nvPicPr>
+          <p:cNvPr id="3" name="Media 0">
+            <a:hlinkClick r:id="" action="ppaction://media"/>
+          </p:cNvPr>
+          <p:cNvPicPr>
+            <a:picLocks noChangeAspect="1"/>
+          </p:cNvPicPr>
+          <p:nvPr>
+            <a:videoFile r:link="rId1"/>
+            <p:extLst>
+              <p:ext uri="{DAA4B4D4-6D71-4841-9C94-3DE7FCFB9230}">
+                <p14:media xmlns:p14="http://schemas.microsoft.com/office/powerpoint/2010/main" r:embed="rId2"/>
+              </p:ext>
+            </p:extLst>
+          </p:nvPr>
+        </p:nvPicPr>
+        <p:blipFill>
+          <a:blip r:embed="rId3"/>
+          <a:stretch>
+            <a:fillRect/>
+          </a:stretch>
+        </p:blipFill>
+        <p:spPr>
+          <a:xfrm>
+            <a:off x="11475720" y="164592"/>
+            <a:ext cx="384048" cy="384048"/>
+          </a:xfrm>
+          <a:prstGeom prst="rect">
+            <a:avLst/>
+          </a:prstGeom>
+        </p:spPr>
+      </p:pic>
       <p:sp>
         <p:nvSpPr>
           <p:cNvPr id="25" name="Slide Number Placeholder 0"/>
@@ -8307,6 +8571,39 @@
           </a:p>
         </p:txBody>
       </p:sp>
+      <p:pic>
+        <p:nvPicPr>
+          <p:cNvPr id="3" name="Media 0">
+            <a:hlinkClick r:id="" action="ppaction://media"/>
+          </p:cNvPr>
+          <p:cNvPicPr>
+            <a:picLocks noChangeAspect="1"/>
+          </p:cNvPicPr>
+          <p:nvPr>
+            <a:videoFile r:link="rId1"/>
+            <p:extLst>
+              <p:ext uri="{DAA4B4D4-6D71-4841-9C94-3DE7FCFB9230}">
+                <p14:media xmlns:p14="http://schemas.microsoft.com/office/powerpoint/2010/main" r:embed="rId2"/>
+              </p:ext>
+            </p:extLst>
+          </p:nvPr>
+        </p:nvPicPr>
+        <p:blipFill>
+          <a:blip r:embed="rId3"/>
+          <a:stretch>
+            <a:fillRect/>
+          </a:stretch>
+        </p:blipFill>
+        <p:spPr>
+          <a:xfrm>
+            <a:off x="11475720" y="164592"/>
+            <a:ext cx="384048" cy="384048"/>
+          </a:xfrm>
+          <a:prstGeom prst="rect">
+            <a:avLst/>
+          </a:prstGeom>
+        </p:spPr>
+      </p:pic>
       <p:sp>
         <p:nvSpPr>
           <p:cNvPr id="25" name="Slide Number Placeholder 0"/>
@@ -9423,6 +9720,39 @@
           </a:p>
         </p:txBody>
       </p:sp>
+      <p:pic>
+        <p:nvPicPr>
+          <p:cNvPr id="3" name="Media 0">
+            <a:hlinkClick r:id="" action="ppaction://media"/>
+          </p:cNvPr>
+          <p:cNvPicPr>
+            <a:picLocks noChangeAspect="1"/>
+          </p:cNvPicPr>
+          <p:nvPr>
+            <a:videoFile r:link="rId1"/>
+            <p:extLst>
+              <p:ext uri="{DAA4B4D4-6D71-4841-9C94-3DE7FCFB9230}">
+                <p14:media xmlns:p14="http://schemas.microsoft.com/office/powerpoint/2010/main" r:embed="rId2"/>
+              </p:ext>
+            </p:extLst>
+          </p:nvPr>
+        </p:nvPicPr>
+        <p:blipFill>
+          <a:blip r:embed="rId3"/>
+          <a:stretch>
+            <a:fillRect/>
+          </a:stretch>
+        </p:blipFill>
+        <p:spPr>
+          <a:xfrm>
+            <a:off x="11475720" y="164592"/>
+            <a:ext cx="384048" cy="384048"/>
+          </a:xfrm>
+          <a:prstGeom prst="rect">
+            <a:avLst/>
+          </a:prstGeom>
+        </p:spPr>
+      </p:pic>
       <p:sp>
         <p:nvSpPr>
           <p:cNvPr id="25" name="Slide Number Placeholder 0"/>
@@ -10434,6 +10764,39 @@
           </a:p>
         </p:txBody>
       </p:sp>
+      <p:pic>
+        <p:nvPicPr>
+          <p:cNvPr id="6" name="Media 0">
+            <a:hlinkClick r:id="" action="ppaction://media"/>
+          </p:cNvPr>
+          <p:cNvPicPr>
+            <a:picLocks noChangeAspect="1"/>
+          </p:cNvPicPr>
+          <p:nvPr>
+            <a:videoFile r:link="rId4"/>
+            <p:extLst>
+              <p:ext uri="{DAA4B4D4-6D71-4841-9C94-3DE7FCFB9230}">
+                <p14:media xmlns:p14="http://schemas.microsoft.com/office/powerpoint/2010/main" r:embed="rId5"/>
+              </p:ext>
+            </p:extLst>
+          </p:nvPr>
+        </p:nvPicPr>
+        <p:blipFill>
+          <a:blip r:embed="rId6"/>
+          <a:stretch>
+            <a:fillRect/>
+          </a:stretch>
+        </p:blipFill>
+        <p:spPr>
+          <a:xfrm>
+            <a:off x="11475720" y="164592"/>
+            <a:ext cx="384048" cy="384048"/>
+          </a:xfrm>
+          <a:prstGeom prst="rect">
+            <a:avLst/>
+          </a:prstGeom>
+        </p:spPr>
+      </p:pic>
       <p:sp>
         <p:nvSpPr>
           <p:cNvPr id="25" name="Slide Number Placeholder 0"/>
@@ -11520,6 +11883,39 @@
           </a:p>
         </p:txBody>
       </p:sp>
+      <p:pic>
+        <p:nvPicPr>
+          <p:cNvPr id="3" name="Media 0">
+            <a:hlinkClick r:id="" action="ppaction://media"/>
+          </p:cNvPr>
+          <p:cNvPicPr>
+            <a:picLocks noChangeAspect="1"/>
+          </p:cNvPicPr>
+          <p:nvPr>
+            <a:videoFile r:link="rId1"/>
+            <p:extLst>
+              <p:ext uri="{DAA4B4D4-6D71-4841-9C94-3DE7FCFB9230}">
+                <p14:media xmlns:p14="http://schemas.microsoft.com/office/powerpoint/2010/main" r:embed="rId2"/>
+              </p:ext>
+            </p:extLst>
+          </p:nvPr>
+        </p:nvPicPr>
+        <p:blipFill>
+          <a:blip r:embed="rId3"/>
+          <a:stretch>
+            <a:fillRect/>
+          </a:stretch>
+        </p:blipFill>
+        <p:spPr>
+          <a:xfrm>
+            <a:off x="11475720" y="164592"/>
+            <a:ext cx="384048" cy="384048"/>
+          </a:xfrm>
+          <a:prstGeom prst="rect">
+            <a:avLst/>
+          </a:prstGeom>
+        </p:spPr>
+      </p:pic>
       <p:sp>
         <p:nvSpPr>
           <p:cNvPr id="25" name="Slide Number Placeholder 0"/>

</xml_diff>

<commit_message>
Shorten FHL showcase narration
Co-authored-by: Copilot <223556219+Copilot@users.noreply.github.com>

Copilot-Session: 0f63ea4f-a16b-4fa3-b141-785aec89b5e4
</commit_message>
<xml_diff>
--- a/FHL-Accessibility-Tree-Diff.pptx
+++ b/FHL-Accessibility-Tree-Diff.pptx
@@ -514,7 +514,7 @@
           <a:p>
             <a:r>
               <a:rPr lang="en-US" dirty="0"/>
-              <a:t>Welcome to our FHL project showcase. We built Accessibility Tree Snapshot and Diff for React Native Windows. Its purpose is simple: catch accessibility regressions that visual review cannot see, and catch them before they ship. During FHL, we took this from an idea to a tested, hardened, working developer tool, with a real React Native Gallery demonstration.</a:t>
+              <a:t>Accessibility Tree Snapshot and Diff catches RNW accessibility regressions that visual review cannot see. During FHL, we built, tested, hardened, and demonstrated the complete tool.</a:t>
             </a:r>
             <a:endParaRPr lang="en-US" dirty="0"/>
           </a:p>
@@ -602,7 +602,7 @@
           <a:p>
             <a:r>
               <a:rPr lang="en-US" dirty="0"/>
-              <a:t>The overall impact is to shift accessibility into normal engineering review. Today, visual review may pass, manual validation happens later, and engineers then reconstruct the cause from a bug. With this project, a baseline travels with the scenario, the diff exposes the semantic change, continuous integration can block the regression, and reviewers receive exact evidence. That means faster diagnosis, safer framework evolution, and fewer customer-found issues.</a:t>
+              <a:t>The impact is earlier discovery, faster diagnosis, stronger pull request evidence, safer framework evolution, and fewer accessibility regressions found by customers.</a:t>
             </a:r>
             <a:endParaRPr lang="en-US" dirty="0"/>
           </a:p>
@@ -690,7 +690,7 @@
           <a:p>
             <a:r>
               <a:rPr lang="en-US" dirty="0"/>
-              <a:t>Assuming merge, the tool lives under packages, at RNW Scripts, Accessibility Diagnostics. Engineers run it through the existing Yarn workspace command. The current FHL implementation is available on the accessibility tree diff branch at commit 6909efe740. Its README documents target selection, capture limits, report formats, exit codes, privacy guidance, and incomplete snapshot behavior.</a:t>
+              <a:t>After merge, engineers find the tool under RNW Scripts Accessibility Diagnostics and run it through the existing Yarn workspace. The FHL branch is available now.</a:t>
             </a:r>
             <a:endParaRPr lang="en-US" dirty="0"/>
           </a:p>
@@ -778,7 +778,7 @@
           <a:p>
             <a:r>
               <a:rPr lang="en-US" dirty="0"/>
-              <a:t>The architecture deliberately supports follow-on projects. The most compelling extension is a Focus Path Recorder that flags loops, unexpected jumps, unnamed targets, and offscreen focus. Other next steps include automated pull request comments, approved RNTester and Gallery baseline catalogs, an interactive tree explorer, component-specific rules, and comparison matrices across architectures, releases, and Windows versions.</a:t>
+              <a:t>Next steps include a Focus Path Recorder, automated pull request reports, approved component baselines, an interactive explorer, rule plug-ins, and cross-release comparison.</a:t>
             </a:r>
             <a:endParaRPr lang="en-US" dirty="0"/>
           </a:p>
@@ -866,7 +866,7 @@
           <a:p>
             <a:r>
               <a:rPr lang="en-US" dirty="0"/>
-              <a:t>Accessibility should not depend on someone noticing what cannot be seen. This project makes hidden semantic regressions visible, reviewable, and enforceable. Capture the tree. Compare the change. Catch the regression. Block it before merge. That is how we shift accessibility left. Thank you.</a:t>
+              <a:t>Accessibility should not depend on noticing what cannot be seen. Capture, compare, catch, and block the regression before merge. Shift accessibility left. Thank you.</a:t>
             </a:r>
             <a:endParaRPr lang="en-US" dirty="0"/>
           </a:p>
@@ -954,7 +954,7 @@
           <a:p>
             <a:r>
               <a:rPr lang="en-US" dirty="0"/>
-              <a:t>Here is the core problem. These two Gallery builds look identical. A screenshot comparison would pass, and a visual reviewer would see no change. But in the build on the right, Item 3 can no longer receive keyboard focus. For keyboard and screen reader users, that is a real product regression. Today, failures like this are often discovered only during late manual validation.</a:t>
+              <a:t>These Gallery builds look identical. Yet Item 3 in the broken build cannot receive keyboard focus. That invisible difference can block keyboard and screen reader users.</a:t>
             </a:r>
             <a:endParaRPr lang="en-US" dirty="0"/>
           </a:p>
@@ -1042,7 +1042,7 @@
           <a:p>
             <a:r>
               <a:rPr lang="en-US" dirty="0"/>
-              <a:t>The project acts as a before-and-after detector for what assistive technology sees. It captures the Windows UI Automation tree, removes volatile and sensitive properties, matches stable elements, classifies meaningful changes, and produces console, JSON, or Markdown evidence. It is external and read-only, so existing applications need no instrumentation and RNW runtime behavior is not modified.</a:t>
+              <a:t>The tool captures two Windows UI Automation trees, normalizes them, matches stable elements, classifies risky changes, and produces reviewable evidence. It is external and read-only.</a:t>
             </a:r>
             <a:endParaRPr lang="en-US" dirty="0"/>
           </a:p>
@@ -1130,7 +1130,7 @@
           <a:p>
             <a:r>
               <a:rPr lang="en-US" dirty="0"/>
-              <a:t>The workflow is intentionally small. First, capture a known-good application tree. Second, capture the application after the code change. Third, diff both snapshots and ask the tool to fail on potential regressions. Exit code one makes the result directly usable in continuous integration. This turns accessibility from an assumption into an artifact that reviewers can inspect and automation can enforce.</a:t>
+              <a:t>The workflow is three commands: capture before, capture after, then diff. A potential regression returns exit code one, making the result ready for continuous integration.</a:t>
             </a:r>
             <a:endParaRPr lang="en-US" dirty="0"/>
           </a:p>
@@ -1218,7 +1218,7 @@
           <a:p>
             <a:r>
               <a:rPr lang="en-US" dirty="0"/>
-              <a:t>This is most valuable where implementation changes can alter semantics without changing pixels. Examples include Fabric migrations, native component refactors, accessibility bug fixes, dependency upgrades, and release validation. It can also become a pull request quality gate that catches removed controls, lost accessible names, changed roles, reordered elements, or controls that silently lose keyboard focusability.</a:t>
+              <a:t>It is especially useful for Fabric migrations, native refactors, accessibility fixes, dependency upgrades, release validation, and pull requests where semantics may change without pixels changing.</a:t>
             </a:r>
             <a:endParaRPr lang="en-US" dirty="0"/>
           </a:p>
@@ -1306,7 +1306,7 @@
           <a:p>
             <a:r>
               <a:rPr lang="en-US" dirty="0"/>
-              <a:t>A useful diff must be trustworthy. The collector traverses incrementally and enforces node and depth limits before expanding the tree. Matching stays within an already matched parent to avoid cascading false differences. Incomplete captures are explicit and rejected by default. The schema is deterministic, privacy-sensitive values are excluded, and externally supplied text is sanitized before console or Markdown rendering. Fifteen tests and live Windows validation cover the risky paths.</a:t>
+              <a:t>Trustworthy results require bounded traversal, stable sibling matching, explicit incomplete captures, deterministic snapshots, privacy-safe properties, and hardened output. Fifteen tests cover the risky behavior.</a:t>
             </a:r>
             <a:endParaRPr lang="en-US" dirty="0"/>
           </a:p>
@@ -1482,7 +1482,7 @@
           <a:p>
             <a:r>
               <a:rPr lang="en-US" dirty="0"/>
-              <a:t>The demonstration proves the key claim. The healthy and broken Gallery screenshots remain visually identical. A single shared renderer change makes Item 3 unfocusable in five different FlatList examples. The tool finds all five changes, classifies each one as a potential regression, and returns exit code one. This is precisely the type of failure that is easy to miss in review but expensive to discover after integration.</a:t>
+              <a:t>The demo proves the value: one invisible Gallery change propagates to five FlatList examples. The tool catches all five and fails the quality gate.</a:t>
             </a:r>
             <a:endParaRPr lang="en-US" dirty="0"/>
           </a:p>
@@ -1570,7 +1570,7 @@
           <a:p>
             <a:r>
               <a:rPr lang="en-US" dirty="0"/>
-              <a:t>This is a working implementation rather than a design mockup. The package has fifteen automated tests, a warning-free release build, and live capture and diff validation against Windows applications. In the Gallery scenario it catches five propagated regressions from one source change. Because the tool is standalone and read-only, it provides immediate value with low risk to RNW product behavior.</a:t>
+              <a:t>This is working software: fifteen tests, zero build warnings, live Windows validation, and five real Gallery regressions detected with no RNW runtime changes.</a:t>
             </a:r>
             <a:endParaRPr lang="en-US" dirty="0"/>
           </a:p>

</xml_diff>

<commit_message>
Refine FHL slides and natural narration
Co-authored-by: Copilot <223556219+Copilot@users.noreply.github.com>

Copilot-Session: 0f63ea4f-a16b-4fa3-b141-785aec89b5e4
</commit_message>
<xml_diff>
--- a/FHL-Accessibility-Tree-Diff.pptx
+++ b/FHL-Accessibility-Tree-Diff.pptx
@@ -514,7 +514,7 @@
           <a:p>
             <a:r>
               <a:rPr lang="en-US" dirty="0"/>
-              <a:t>Accessibility Tree Snapshot and Diff catches RNW accessibility regressions that visual review cannot see. During FHL, we built, tested, hardened, and demonstrated the complete tool.</a:t>
+              <a:t>Hi everyone. Here's what we built during FHL: a tool that catches React Native Windows accessibility regressions you simply can't see in a screenshot.</a:t>
             </a:r>
             <a:endParaRPr lang="en-US" dirty="0"/>
           </a:p>
@@ -602,7 +602,7 @@
           <a:p>
             <a:r>
               <a:rPr lang="en-US" dirty="0"/>
-              <a:t>The impact is earlier discovery, faster diagnosis, stronger pull request evidence, safer framework evolution, and fewer accessibility regressions found by customers.</a:t>
+              <a:t>The bigger win is timing. Instead of discovering accessibility problems at the end, engineers get clear evidence while the change is still in review.</a:t>
             </a:r>
             <a:endParaRPr lang="en-US" dirty="0"/>
           </a:p>
@@ -690,7 +690,7 @@
           <a:p>
             <a:r>
               <a:rPr lang="en-US" dirty="0"/>
-              <a:t>After merge, engineers find the tool under RNW Scripts Accessibility Diagnostics and run it through the existing Yarn workspace. The FHL branch is available now.</a:t>
+              <a:t>Once merged, the tool fits into the existing RNW workspace. The FHL branch and full documentation are already available for anyone who wants to try it.</a:t>
             </a:r>
             <a:endParaRPr lang="en-US" dirty="0"/>
           </a:p>
@@ -778,7 +778,7 @@
           <a:p>
             <a:r>
               <a:rPr lang="en-US" dirty="0"/>
-              <a:t>Next steps include a Focus Path Recorder, automated pull request reports, approved component baselines, an interactive explorer, rule plug-ins, and cross-release comparison.</a:t>
+              <a:t>From here, the top priorities are automatic pull-request checks, a keyboard focus recorder, and a visual explorer that makes reviewing diffs even easier.</a:t>
             </a:r>
             <a:endParaRPr lang="en-US" dirty="0"/>
           </a:p>
@@ -866,7 +866,7 @@
           <a:p>
             <a:r>
               <a:rPr lang="en-US" dirty="0"/>
-              <a:t>Accessibility should not depend on noticing what cannot be seen. Capture, compare, catch, and block the regression before merge. Shift accessibility left. Thank you.</a:t>
+              <a:t>So that's the project: make the invisible visible, catch it early, and stop it before merge. That's what shifting accessibility left looks like. Thank you.</a:t>
             </a:r>
             <a:endParaRPr lang="en-US" dirty="0"/>
           </a:p>
@@ -954,7 +954,7 @@
           <a:p>
             <a:r>
               <a:rPr lang="en-US" dirty="0"/>
-              <a:t>These Gallery builds look identical. Yet Item 3 in the broken build cannot receive keyboard focus. That invisible difference can block keyboard and screen reader users.</a:t>
+              <a:t>Take a look at these two Gallery builds. They appear identical. But on the right, Item 3 has quietly dropped out of keyboard navigation. That's the problem we're solving.</a:t>
             </a:r>
             <a:endParaRPr lang="en-US" dirty="0"/>
           </a:p>
@@ -1042,7 +1042,7 @@
           <a:p>
             <a:r>
               <a:rPr lang="en-US" dirty="0"/>
-              <a:t>The tool captures two Windows UI Automation trees, normalizes them, matches stable elements, classifies risky changes, and produces reviewable evidence. It is external and read-only.</a:t>
+              <a:t>The idea is straightforward. Capture what assistive technology sees before a change, capture it again afterward, and highlight only the accessibility differences that deserve attention.</a:t>
             </a:r>
             <a:endParaRPr lang="en-US" dirty="0"/>
           </a:p>
@@ -1130,7 +1130,7 @@
           <a:p>
             <a:r>
               <a:rPr lang="en-US" dirty="0"/>
-              <a:t>The workflow is three commands: capture before, capture after, then diff. A potential regression returns exit code one, making the result ready for continuous integration.</a:t>
+              <a:t>For an engineer, it's just three steps: capture before, capture after, and compare. If the change looks risky, exit code one can stop the pull request.</a:t>
             </a:r>
             <a:endParaRPr lang="en-US" dirty="0"/>
           </a:p>
@@ -1218,7 +1218,7 @@
           <a:p>
             <a:r>
               <a:rPr lang="en-US" dirty="0"/>
-              <a:t>It is especially useful for Fabric migrations, native refactors, accessibility fixes, dependency upgrades, release validation, and pull requests where semantics may change without pixels changing.</a:t>
+              <a:t>This really helps when pixels stay the same but semantics may shift—during Fabric migrations, native refactors, dependency upgrades, accessibility fixes, and release validation.</a:t>
             </a:r>
             <a:endParaRPr lang="en-US" dirty="0"/>
           </a:p>
@@ -1306,7 +1306,7 @@
           <a:p>
             <a:r>
               <a:rPr lang="en-US" dirty="0"/>
-              <a:t>Trustworthy results require bounded traversal, stable sibling matching, explicit incomplete captures, deterministic snapshots, privacy-safe properties, and hardened output. Fifteen tests cover the risky behavior.</a:t>
+              <a:t>We also worked hard to make the results trustworthy: scans are bounded, matching avoids noisy cascades, interrupted scans can't look clean, and sensitive application data stays out.</a:t>
             </a:r>
             <a:endParaRPr lang="en-US" dirty="0"/>
           </a:p>
@@ -1394,7 +1394,7 @@
           <a:p>
             <a:r>
               <a:rPr lang="en-US" dirty="0"/>
-              <a:t>Play the embedded narrated Gallery demonstration. It shows the healthy baseline, the visually identical regression, the five issues detected by the tool, and the CI-blocking exit code.</a:t>
+              <a:t>Here's the live proof. We start with the real React Native Gallery and capture a healthy FlatList page. Then we make one tiny change: Item 3 is no longer keyboard focusable. Visually, nothing moves. We capture again and run the diff. Because that renderer is reused, the tool finds the same regression in five examples—and returns exit code one, ready to block the change.</a:t>
             </a:r>
             <a:endParaRPr lang="en-US" dirty="0"/>
           </a:p>
@@ -1482,7 +1482,7 @@
           <a:p>
             <a:r>
               <a:rPr lang="en-US" dirty="0"/>
-              <a:t>The demo proves the value: one invisible Gallery change propagates to five FlatList examples. The tool catches all five and fails the quality gate.</a:t>
+              <a:t>And this is the result at a glance: same-looking screens, five real keyboard regressions, and a precise explanation of what changed.</a:t>
             </a:r>
             <a:endParaRPr lang="en-US" dirty="0"/>
           </a:p>
@@ -1570,7 +1570,7 @@
           <a:p>
             <a:r>
               <a:rPr lang="en-US" dirty="0"/>
-              <a:t>This is working software: fifteen tests, zero build warnings, live Windows validation, and five real Gallery regressions detected with no RNW runtime changes.</a:t>
+              <a:t>This isn't just a concept. We finished the working tool, added fifteen tests, reached a warning-free build, and validated it against live Windows applications.</a:t>
             </a:r>
             <a:endParaRPr lang="en-US" dirty="0"/>
           </a:p>
@@ -4364,7 +4364,7 @@
                 <a:ea typeface="Segoe UI" pitchFamily="34" charset="-122"/>
                 <a:cs typeface="Segoe UI" pitchFamily="34" charset="-120"/>
               </a:rPr>
-              <a:t>POTENTIAL EXTENSIONS</a:t>
+              <a:t>TOP NEXT STEPS</a:t>
             </a:r>
             <a:endParaRPr lang="en-US" sz="1100" dirty="0"/>
           </a:p>
@@ -4403,7 +4403,7 @@
                 <a:ea typeface="Segoe UI" pitchFamily="34" charset="-122"/>
                 <a:cs typeface="Segoe UI" pitchFamily="34" charset="-120"/>
               </a:rPr>
-              <a:t>The snapshot engine is the foundation, not the finish line.</a:t>
+              <a:t>Turn the working prototype into an everyday RNW quality gate.</a:t>
             </a:r>
             <a:endParaRPr lang="en-US" sz="3000" dirty="0"/>
           </a:p>
@@ -4442,7 +4442,7 @@
                 <a:ea typeface="Segoe UI" pitchFamily="34" charset="-122"/>
                 <a:cs typeface="Segoe UI" pitchFamily="34" charset="-120"/>
               </a:rPr>
-              <a:t>Each extension reuses the same target selection, UIA reader, model, serialization, and reporting layers.</a:t>
+              <a:t>These three extensions deliver the clearest engineering and customer impact.</a:t>
             </a:r>
             <a:endParaRPr lang="en-US" sz="1500" dirty="0"/>
           </a:p>
@@ -4456,12 +4456,12 @@
         </p:nvSpPr>
         <p:spPr>
           <a:xfrm>
-            <a:off x="640080" y="1828800"/>
-            <a:ext cx="3474720" cy="1234440"/>
+            <a:off x="640080" y="2057400"/>
+            <a:ext cx="3474720" cy="2468880"/>
           </a:xfrm>
           <a:prstGeom prst="roundRect">
             <a:avLst>
-              <a:gd name="adj" fmla="val 5926"/>
+              <a:gd name="adj" fmla="val 2963"/>
             </a:avLst>
           </a:prstGeom>
           <a:solidFill>
@@ -4483,8 +4483,138 @@
         </p:nvSpPr>
         <p:spPr>
           <a:xfrm>
-            <a:off x="640080" y="1828800"/>
-            <a:ext cx="73152" cy="1234440"/>
+            <a:off x="640080" y="2057400"/>
+            <a:ext cx="73152" cy="2468880"/>
+          </a:xfrm>
+          <a:prstGeom prst="rect">
+            <a:avLst/>
+          </a:prstGeom>
+          <a:solidFill>
+            <a:srgbClr val="0078D4"/>
+          </a:solidFill>
+          <a:ln w="12700">
+            <a:solidFill>
+              <a:srgbClr val="0078D4"/>
+            </a:solidFill>
+            <a:prstDash val="solid"/>
+          </a:ln>
+        </p:spPr>
+      </p:sp>
+      <p:sp>
+        <p:nvSpPr>
+          <p:cNvPr id="8" name="Text 6"/>
+          <p:cNvSpPr/>
+          <p:nvPr/>
+        </p:nvSpPr>
+        <p:spPr>
+          <a:xfrm>
+            <a:off x="868680" y="2221992"/>
+            <a:ext cx="3108960" cy="320040"/>
+          </a:xfrm>
+          <a:prstGeom prst="rect">
+            <a:avLst/>
+          </a:prstGeom>
+          <a:noFill/>
+          <a:ln/>
+        </p:spPr>
+        <p:txBody>
+          <a:bodyPr wrap="square" lIns="0" tIns="0" rIns="0" bIns="0" rtlCol="0" anchor="ctr"/>
+          <a:lstStyle/>
+          <a:p>
+            <a:pPr indent="0" marL="0">
+              <a:buNone/>
+            </a:pPr>
+            <a:r>
+              <a:rPr lang="en-US" sz="1600" b="1" dirty="0">
+                <a:solidFill>
+                  <a:srgbClr val="172033"/>
+                </a:solidFill>
+                <a:latin typeface="Segoe UI" pitchFamily="34" charset="0"/>
+                <a:ea typeface="Segoe UI" pitchFamily="34" charset="-122"/>
+                <a:cs typeface="Segoe UI" pitchFamily="34" charset="-120"/>
+              </a:rPr>
+              <a:t>1 · Automatic PR checks</a:t>
+            </a:r>
+            <a:endParaRPr lang="en-US" sz="1600" dirty="0"/>
+          </a:p>
+        </p:txBody>
+      </p:sp>
+      <p:sp>
+        <p:nvSpPr>
+          <p:cNvPr id="9" name="Text 7"/>
+          <p:cNvSpPr/>
+          <p:nvPr/>
+        </p:nvSpPr>
+        <p:spPr>
+          <a:xfrm>
+            <a:off x="868680" y="2624328"/>
+            <a:ext cx="3108960" cy="1755648"/>
+          </a:xfrm>
+          <a:prstGeom prst="rect">
+            <a:avLst/>
+          </a:prstGeom>
+          <a:noFill/>
+          <a:ln/>
+        </p:spPr>
+        <p:txBody>
+          <a:bodyPr wrap="square" lIns="0" tIns="0" rIns="0" bIns="0" rtlCol="0" anchor="t"/>
+          <a:lstStyle/>
+          <a:p>
+            <a:pPr indent="0" marL="0">
+              <a:buNone/>
+            </a:pPr>
+            <a:r>
+              <a:rPr lang="en-US" sz="1150" dirty="0">
+                <a:solidFill>
+                  <a:srgbClr val="5E6A7D"/>
+                </a:solidFill>
+                <a:latin typeface="Segoe UI" pitchFamily="34" charset="0"/>
+                <a:ea typeface="Segoe UI" pitchFamily="34" charset="-122"/>
+                <a:cs typeface="Segoe UI" pitchFamily="34" charset="-120"/>
+              </a:rPr>
+              <a:t>Run approved Gallery and RNTester scenarios in CI. Post the accessibility diff directly on the pull request and block newly introduced regressions.</a:t>
+            </a:r>
+            <a:endParaRPr lang="en-US" sz="1150" dirty="0"/>
+          </a:p>
+        </p:txBody>
+      </p:sp>
+      <p:sp>
+        <p:nvSpPr>
+          <p:cNvPr id="10" name="Shape 8"/>
+          <p:cNvSpPr/>
+          <p:nvPr/>
+        </p:nvSpPr>
+        <p:spPr>
+          <a:xfrm>
+            <a:off x="4343400" y="2057400"/>
+            <a:ext cx="3474720" cy="2468880"/>
+          </a:xfrm>
+          <a:prstGeom prst="roundRect">
+            <a:avLst>
+              <a:gd name="adj" fmla="val 2963"/>
+            </a:avLst>
+          </a:prstGeom>
+          <a:solidFill>
+            <a:srgbClr val="F7F9FC"/>
+          </a:solidFill>
+          <a:ln w="12700">
+            <a:solidFill>
+              <a:srgbClr val="D9E2EC"/>
+            </a:solidFill>
+            <a:prstDash val="solid"/>
+          </a:ln>
+        </p:spPr>
+      </p:sp>
+      <p:sp>
+        <p:nvSpPr>
+          <p:cNvPr id="11" name="Shape 9"/>
+          <p:cNvSpPr/>
+          <p:nvPr/>
+        </p:nvSpPr>
+        <p:spPr>
+          <a:xfrm>
+            <a:off x="4343400" y="2057400"/>
+            <a:ext cx="73152" cy="2468880"/>
           </a:xfrm>
           <a:prstGeom prst="rect">
             <a:avLst/>
@@ -4502,13 +4632,13 @@
       </p:sp>
       <p:sp>
         <p:nvSpPr>
-          <p:cNvPr id="8" name="Text 6"/>
-          <p:cNvSpPr/>
-          <p:nvPr/>
-        </p:nvSpPr>
-        <p:spPr>
-          <a:xfrm>
-            <a:off x="868680" y="1993392"/>
+          <p:cNvPr id="12" name="Text 10"/>
+          <p:cNvSpPr/>
+          <p:nvPr/>
+        </p:nvSpPr>
+        <p:spPr>
+          <a:xfrm>
+            <a:off x="4572000" y="2221992"/>
             <a:ext cx="3108960" cy="320040"/>
           </a:xfrm>
           <a:prstGeom prst="rect">
@@ -4533,7 +4663,7 @@
                 <a:ea typeface="Segoe UI" pitchFamily="34" charset="-122"/>
                 <a:cs typeface="Segoe UI" pitchFamily="34" charset="-120"/>
               </a:rPr>
-              <a:t>Focus Path Recorder</a:t>
+              <a:t>2 · Keyboard focus recorder</a:t>
             </a:r>
             <a:endParaRPr lang="en-US" sz="1600" dirty="0"/>
           </a:p>
@@ -4541,14 +4671,14 @@
       </p:sp>
       <p:sp>
         <p:nvSpPr>
-          <p:cNvPr id="9" name="Text 7"/>
-          <p:cNvSpPr/>
-          <p:nvPr/>
-        </p:nvSpPr>
-        <p:spPr>
-          <a:xfrm>
-            <a:off x="868680" y="2395728"/>
-            <a:ext cx="3108960" cy="521208"/>
+          <p:cNvPr id="13" name="Text 11"/>
+          <p:cNvSpPr/>
+          <p:nvPr/>
+        </p:nvSpPr>
+        <p:spPr>
+          <a:xfrm>
+            <a:off x="4572000" y="2624328"/>
+            <a:ext cx="3108960" cy="1755648"/>
           </a:xfrm>
           <a:prstGeom prst="rect">
             <a:avLst/>
@@ -4572,7 +4702,7 @@
                 <a:ea typeface="Segoe UI" pitchFamily="34" charset="-122"/>
                 <a:cs typeface="Segoe UI" pitchFamily="34" charset="-120"/>
               </a:rPr>
-              <a:t>Record every keyboard-focus transition and flag loops, jumps, unnamed targets, and offscreen focus.</a:t>
+              <a:t>Record where keyboard focus moves and flag loops, unexpected jumps, missing labels, or focus landing on hidden content.</a:t>
             </a:r>
             <a:endParaRPr lang="en-US" sz="1150" dirty="0"/>
           </a:p>
@@ -4580,18 +4710,18 @@
       </p:sp>
       <p:sp>
         <p:nvSpPr>
-          <p:cNvPr id="10" name="Shape 8"/>
-          <p:cNvSpPr/>
-          <p:nvPr/>
-        </p:nvSpPr>
-        <p:spPr>
-          <a:xfrm>
-            <a:off x="4343400" y="1828800"/>
-            <a:ext cx="3474720" cy="1234440"/>
+          <p:cNvPr id="14" name="Shape 12"/>
+          <p:cNvSpPr/>
+          <p:nvPr/>
+        </p:nvSpPr>
+        <p:spPr>
+          <a:xfrm>
+            <a:off x="8046720" y="2057400"/>
+            <a:ext cx="3474720" cy="2468880"/>
           </a:xfrm>
           <a:prstGeom prst="roundRect">
             <a:avLst>
-              <a:gd name="adj" fmla="val 5926"/>
+              <a:gd name="adj" fmla="val 2963"/>
             </a:avLst>
           </a:prstGeom>
           <a:solidFill>
@@ -4607,144 +4737,14 @@
       </p:sp>
       <p:sp>
         <p:nvSpPr>
-          <p:cNvPr id="11" name="Shape 9"/>
-          <p:cNvSpPr/>
-          <p:nvPr/>
-        </p:nvSpPr>
-        <p:spPr>
-          <a:xfrm>
-            <a:off x="4343400" y="1828800"/>
-            <a:ext cx="73152" cy="1234440"/>
-          </a:xfrm>
-          <a:prstGeom prst="rect">
-            <a:avLst/>
-          </a:prstGeom>
-          <a:solidFill>
-            <a:srgbClr val="0078D4"/>
-          </a:solidFill>
-          <a:ln w="12700">
-            <a:solidFill>
-              <a:srgbClr val="0078D4"/>
-            </a:solidFill>
-            <a:prstDash val="solid"/>
-          </a:ln>
-        </p:spPr>
-      </p:sp>
-      <p:sp>
-        <p:nvSpPr>
-          <p:cNvPr id="12" name="Text 10"/>
-          <p:cNvSpPr/>
-          <p:nvPr/>
-        </p:nvSpPr>
-        <p:spPr>
-          <a:xfrm>
-            <a:off x="4572000" y="1993392"/>
-            <a:ext cx="3108960" cy="320040"/>
-          </a:xfrm>
-          <a:prstGeom prst="rect">
-            <a:avLst/>
-          </a:prstGeom>
-          <a:noFill/>
-          <a:ln/>
-        </p:spPr>
-        <p:txBody>
-          <a:bodyPr wrap="square" lIns="0" tIns="0" rIns="0" bIns="0" rtlCol="0" anchor="ctr"/>
-          <a:lstStyle/>
-          <a:p>
-            <a:pPr indent="0" marL="0">
-              <a:buNone/>
-            </a:pPr>
-            <a:r>
-              <a:rPr lang="en-US" sz="1600" b="1" dirty="0">
-                <a:solidFill>
-                  <a:srgbClr val="172033"/>
-                </a:solidFill>
-                <a:latin typeface="Segoe UI" pitchFamily="34" charset="0"/>
-                <a:ea typeface="Segoe UI" pitchFamily="34" charset="-122"/>
-                <a:cs typeface="Segoe UI" pitchFamily="34" charset="-120"/>
-              </a:rPr>
-              <a:t>PR automation</a:t>
-            </a:r>
-            <a:endParaRPr lang="en-US" sz="1600" dirty="0"/>
-          </a:p>
-        </p:txBody>
-      </p:sp>
-      <p:sp>
-        <p:nvSpPr>
-          <p:cNvPr id="13" name="Text 11"/>
-          <p:cNvSpPr/>
-          <p:nvPr/>
-        </p:nvSpPr>
-        <p:spPr>
-          <a:xfrm>
-            <a:off x="4572000" y="2395728"/>
-            <a:ext cx="3108960" cy="521208"/>
-          </a:xfrm>
-          <a:prstGeom prst="rect">
-            <a:avLst/>
-          </a:prstGeom>
-          <a:noFill/>
-          <a:ln/>
-        </p:spPr>
-        <p:txBody>
-          <a:bodyPr wrap="square" lIns="0" tIns="0" rIns="0" bIns="0" rtlCol="0" anchor="t"/>
-          <a:lstStyle/>
-          <a:p>
-            <a:pPr indent="0" marL="0">
-              <a:buNone/>
-            </a:pPr>
-            <a:r>
-              <a:rPr lang="en-US" sz="1150" dirty="0">
-                <a:solidFill>
-                  <a:srgbClr val="5E6A7D"/>
-                </a:solidFill>
-                <a:latin typeface="Segoe UI" pitchFamily="34" charset="0"/>
-                <a:ea typeface="Segoe UI" pitchFamily="34" charset="-122"/>
-                <a:cs typeface="Segoe UI" pitchFamily="34" charset="-120"/>
-              </a:rPr>
-              <a:t>GitHub Action captures approved scenarios and posts a Markdown accessibility diff on every PR.</a:t>
-            </a:r>
-            <a:endParaRPr lang="en-US" sz="1150" dirty="0"/>
-          </a:p>
-        </p:txBody>
-      </p:sp>
-      <p:sp>
-        <p:nvSpPr>
-          <p:cNvPr id="14" name="Shape 12"/>
-          <p:cNvSpPr/>
-          <p:nvPr/>
-        </p:nvSpPr>
-        <p:spPr>
-          <a:xfrm>
-            <a:off x="8046720" y="1828800"/>
-            <a:ext cx="3474720" cy="1234440"/>
-          </a:xfrm>
-          <a:prstGeom prst="roundRect">
-            <a:avLst>
-              <a:gd name="adj" fmla="val 5926"/>
-            </a:avLst>
-          </a:prstGeom>
-          <a:solidFill>
-            <a:srgbClr val="F7F9FC"/>
-          </a:solidFill>
-          <a:ln w="12700">
-            <a:solidFill>
-              <a:srgbClr val="D9E2EC"/>
-            </a:solidFill>
-            <a:prstDash val="solid"/>
-          </a:ln>
-        </p:spPr>
-      </p:sp>
-      <p:sp>
-        <p:nvSpPr>
           <p:cNvPr id="15" name="Shape 13"/>
           <p:cNvSpPr/>
           <p:nvPr/>
         </p:nvSpPr>
         <p:spPr>
           <a:xfrm>
-            <a:off x="8046720" y="1828800"/>
-            <a:ext cx="73152" cy="1234440"/>
+            <a:off x="8046720" y="2057400"/>
+            <a:ext cx="73152" cy="2468880"/>
           </a:xfrm>
           <a:prstGeom prst="rect">
             <a:avLst/>
@@ -4768,7 +4768,7 @@
         </p:nvSpPr>
         <p:spPr>
           <a:xfrm>
-            <a:off x="8275320" y="1993392"/>
+            <a:off x="8275320" y="2221992"/>
             <a:ext cx="3108960" cy="320040"/>
           </a:xfrm>
           <a:prstGeom prst="rect">
@@ -4793,7 +4793,7 @@
                 <a:ea typeface="Segoe UI" pitchFamily="34" charset="-122"/>
                 <a:cs typeface="Segoe UI" pitchFamily="34" charset="-120"/>
               </a:rPr>
-              <a:t>Baseline catalog</a:t>
+              <a:t>3 · Visual diff explorer</a:t>
             </a:r>
             <a:endParaRPr lang="en-US" sz="1600" dirty="0"/>
           </a:p>
@@ -4807,8 +4807,8 @@
         </p:nvSpPr>
         <p:spPr>
           <a:xfrm>
-            <a:off x="8275320" y="2395728"/>
-            <a:ext cx="3108960" cy="521208"/>
+            <a:off x="8275320" y="2624328"/>
+            <a:ext cx="3108960" cy="1755648"/>
           </a:xfrm>
           <a:prstGeom prst="rect">
             <a:avLst/>
@@ -4832,7 +4832,7 @@
                 <a:ea typeface="Segoe UI" pitchFamily="34" charset="-122"/>
                 <a:cs typeface="Segoe UI" pitchFamily="34" charset="-120"/>
               </a:rPr>
-              <a:t>Curated snapshots for RNTester and Gallery components across RNW release branches.</a:t>
+              <a:t>Open snapshots in a browser, highlight exactly what changed, and manage approved baselines without reading raw JSON.</a:t>
             </a:r>
             <a:endParaRPr lang="en-US" sz="1150" dirty="0"/>
           </a:p>
@@ -4840,66 +4840,50 @@
       </p:sp>
       <p:sp>
         <p:nvSpPr>
-          <p:cNvPr id="18" name="Shape 16"/>
-          <p:cNvSpPr/>
-          <p:nvPr/>
-        </p:nvSpPr>
-        <p:spPr>
-          <a:xfrm>
-            <a:off x="640080" y="3383280"/>
-            <a:ext cx="3474720" cy="1234440"/>
-          </a:xfrm>
-          <a:prstGeom prst="roundRect">
-            <a:avLst>
-              <a:gd name="adj" fmla="val 5926"/>
-            </a:avLst>
-          </a:prstGeom>
-          <a:solidFill>
-            <a:srgbClr val="F7F9FC"/>
-          </a:solidFill>
-          <a:ln w="12700">
-            <a:solidFill>
-              <a:srgbClr val="D9E2EC"/>
-            </a:solidFill>
-            <a:prstDash val="solid"/>
-          </a:ln>
-        </p:spPr>
-      </p:sp>
-      <p:sp>
-        <p:nvSpPr>
-          <p:cNvPr id="19" name="Shape 17"/>
-          <p:cNvSpPr/>
-          <p:nvPr/>
-        </p:nvSpPr>
-        <p:spPr>
-          <a:xfrm>
-            <a:off x="640080" y="3383280"/>
-            <a:ext cx="73152" cy="1234440"/>
-          </a:xfrm>
-          <a:prstGeom prst="rect">
-            <a:avLst/>
-          </a:prstGeom>
-          <a:solidFill>
-            <a:srgbClr val="FFB900"/>
-          </a:solidFill>
-          <a:ln w="12700">
-            <a:solidFill>
-              <a:srgbClr val="FFB900"/>
-            </a:solidFill>
-            <a:prstDash val="solid"/>
-          </a:ln>
-        </p:spPr>
-      </p:sp>
-      <p:sp>
-        <p:nvSpPr>
-          <p:cNvPr id="20" name="Text 18"/>
-          <p:cNvSpPr/>
-          <p:nvPr/>
-        </p:nvSpPr>
-        <p:spPr>
-          <a:xfrm>
-            <a:off x="868680" y="3547872"/>
-            <a:ext cx="3108960" cy="320040"/>
+          <p:cNvPr id="18" name="Text 16"/>
+          <p:cNvSpPr/>
+          <p:nvPr/>
+        </p:nvSpPr>
+        <p:spPr>
+          <a:xfrm>
+            <a:off x="1188720" y="5166360"/>
+            <a:ext cx="9784080" cy="530352"/>
+          </a:xfrm>
+          <a:prstGeom prst="rect">
+            <a:avLst/>
+          </a:prstGeom>
+          <a:noFill/>
+          <a:ln/>
+        </p:spPr>
+        <p:txBody>
+          <a:bodyPr wrap="square" lIns="0" tIns="0" rIns="0" bIns="0" rtlCol="0" anchor="ctr"/>
+          <a:lstStyle/>
+          <a:p>
+            <a:pPr algn="ctr" indent="0" marL="0">
+              <a:buNone/>
+            </a:pPr>
+            <a:r>
+              <a:rPr lang="en-US" sz="2000" b="1" dirty="0">
+                <a:solidFill>
+                  <a:srgbClr val="071A2B"/>
+                </a:solidFill>
+              </a:rPr>
+              <a:t>First milestone: automate one repeatable RNW Gallery scenario in CI.</a:t>
+            </a:r>
+            <a:endParaRPr lang="en-US" sz="2000" dirty="0"/>
+          </a:p>
+        </p:txBody>
+      </p:sp>
+      <p:sp>
+        <p:nvSpPr>
+          <p:cNvPr id="19" name="Text 17"/>
+          <p:cNvSpPr/>
+          <p:nvPr/>
+        </p:nvSpPr>
+        <p:spPr>
+          <a:xfrm>
+            <a:off x="502920" y="6556248"/>
+            <a:ext cx="6400800" cy="164592"/>
           </a:xfrm>
           <a:prstGeom prst="rect">
             <a:avLst/>
@@ -4915,388 +4899,14 @@
               <a:buNone/>
             </a:pPr>
             <a:r>
-              <a:rPr lang="en-US" sz="1600" b="1" dirty="0">
-                <a:solidFill>
-                  <a:srgbClr val="172033"/>
+              <a:rPr lang="en-US" sz="800" dirty="0">
+                <a:solidFill>
+                  <a:srgbClr val="7C8798"/>
                 </a:solidFill>
                 <a:latin typeface="Segoe UI" pitchFamily="34" charset="0"/>
                 <a:ea typeface="Segoe UI" pitchFamily="34" charset="-122"/>
                 <a:cs typeface="Segoe UI" pitchFamily="34" charset="-120"/>
               </a:rPr>
-              <a:t>Interactive tree explorer</a:t>
-            </a:r>
-            <a:endParaRPr lang="en-US" sz="1600" dirty="0"/>
-          </a:p>
-        </p:txBody>
-      </p:sp>
-      <p:sp>
-        <p:nvSpPr>
-          <p:cNvPr id="21" name="Text 19"/>
-          <p:cNvSpPr/>
-          <p:nvPr/>
-        </p:nvSpPr>
-        <p:spPr>
-          <a:xfrm>
-            <a:off x="868680" y="3950208"/>
-            <a:ext cx="3108960" cy="521208"/>
-          </a:xfrm>
-          <a:prstGeom prst="rect">
-            <a:avLst/>
-          </a:prstGeom>
-          <a:noFill/>
-          <a:ln/>
-        </p:spPr>
-        <p:txBody>
-          <a:bodyPr wrap="square" lIns="0" tIns="0" rIns="0" bIns="0" rtlCol="0" anchor="t"/>
-          <a:lstStyle/>
-          <a:p>
-            <a:pPr indent="0" marL="0">
-              <a:buNone/>
-            </a:pPr>
-            <a:r>
-              <a:rPr lang="en-US" sz="1150" dirty="0">
-                <a:solidFill>
-                  <a:srgbClr val="5E6A7D"/>
-                </a:solidFill>
-                <a:latin typeface="Segoe UI" pitchFamily="34" charset="0"/>
-                <a:ea typeface="Segoe UI" pitchFamily="34" charset="-122"/>
-                <a:cs typeface="Segoe UI" pitchFamily="34" charset="-120"/>
-              </a:rPr>
-              <a:t>HTML visualization with before/after highlighting, filters, and drill-down property inspection.</a:t>
-            </a:r>
-            <a:endParaRPr lang="en-US" sz="1150" dirty="0"/>
-          </a:p>
-        </p:txBody>
-      </p:sp>
-      <p:sp>
-        <p:nvSpPr>
-          <p:cNvPr id="22" name="Shape 20"/>
-          <p:cNvSpPr/>
-          <p:nvPr/>
-        </p:nvSpPr>
-        <p:spPr>
-          <a:xfrm>
-            <a:off x="4343400" y="3383280"/>
-            <a:ext cx="3474720" cy="1234440"/>
-          </a:xfrm>
-          <a:prstGeom prst="roundRect">
-            <a:avLst>
-              <a:gd name="adj" fmla="val 5926"/>
-            </a:avLst>
-          </a:prstGeom>
-          <a:solidFill>
-            <a:srgbClr val="F7F9FC"/>
-          </a:solidFill>
-          <a:ln w="12700">
-            <a:solidFill>
-              <a:srgbClr val="D9E2EC"/>
-            </a:solidFill>
-            <a:prstDash val="solid"/>
-          </a:ln>
-        </p:spPr>
-      </p:sp>
-      <p:sp>
-        <p:nvSpPr>
-          <p:cNvPr id="23" name="Shape 21"/>
-          <p:cNvSpPr/>
-          <p:nvPr/>
-        </p:nvSpPr>
-        <p:spPr>
-          <a:xfrm>
-            <a:off x="4343400" y="3383280"/>
-            <a:ext cx="73152" cy="1234440"/>
-          </a:xfrm>
-          <a:prstGeom prst="rect">
-            <a:avLst/>
-          </a:prstGeom>
-          <a:solidFill>
-            <a:srgbClr val="D13438"/>
-          </a:solidFill>
-          <a:ln w="12700">
-            <a:solidFill>
-              <a:srgbClr val="D13438"/>
-            </a:solidFill>
-            <a:prstDash val="solid"/>
-          </a:ln>
-        </p:spPr>
-      </p:sp>
-      <p:sp>
-        <p:nvSpPr>
-          <p:cNvPr id="24" name="Text 22"/>
-          <p:cNvSpPr/>
-          <p:nvPr/>
-        </p:nvSpPr>
-        <p:spPr>
-          <a:xfrm>
-            <a:off x="4572000" y="3547872"/>
-            <a:ext cx="3108960" cy="320040"/>
-          </a:xfrm>
-          <a:prstGeom prst="rect">
-            <a:avLst/>
-          </a:prstGeom>
-          <a:noFill/>
-          <a:ln/>
-        </p:spPr>
-        <p:txBody>
-          <a:bodyPr wrap="square" lIns="0" tIns="0" rIns="0" bIns="0" rtlCol="0" anchor="ctr"/>
-          <a:lstStyle/>
-          <a:p>
-            <a:pPr indent="0" marL="0">
-              <a:buNone/>
-            </a:pPr>
-            <a:r>
-              <a:rPr lang="en-US" sz="1600" b="1" dirty="0">
-                <a:solidFill>
-                  <a:srgbClr val="172033"/>
-                </a:solidFill>
-                <a:latin typeface="Segoe UI" pitchFamily="34" charset="0"/>
-                <a:ea typeface="Segoe UI" pitchFamily="34" charset="-122"/>
-                <a:cs typeface="Segoe UI" pitchFamily="34" charset="-120"/>
-              </a:rPr>
-              <a:t>Rule plug-ins</a:t>
-            </a:r>
-            <a:endParaRPr lang="en-US" sz="1600" dirty="0"/>
-          </a:p>
-        </p:txBody>
-      </p:sp>
-      <p:sp>
-        <p:nvSpPr>
-          <p:cNvPr id="25" name="Text 23"/>
-          <p:cNvSpPr/>
-          <p:nvPr/>
-        </p:nvSpPr>
-        <p:spPr>
-          <a:xfrm>
-            <a:off x="4572000" y="3950208"/>
-            <a:ext cx="3108960" cy="521208"/>
-          </a:xfrm>
-          <a:prstGeom prst="rect">
-            <a:avLst/>
-          </a:prstGeom>
-          <a:noFill/>
-          <a:ln/>
-        </p:spPr>
-        <p:txBody>
-          <a:bodyPr wrap="square" lIns="0" tIns="0" rIns="0" bIns="0" rtlCol="0" anchor="t"/>
-          <a:lstStyle/>
-          <a:p>
-            <a:pPr indent="0" marL="0">
-              <a:buNone/>
-            </a:pPr>
-            <a:r>
-              <a:rPr lang="en-US" sz="1150" dirty="0">
-                <a:solidFill>
-                  <a:srgbClr val="5E6A7D"/>
-                </a:solidFill>
-                <a:latin typeface="Segoe UI" pitchFamily="34" charset="0"/>
-                <a:ea typeface="Segoe UI" pitchFamily="34" charset="-122"/>
-                <a:cs typeface="Segoe UI" pitchFamily="34" charset="-120"/>
-              </a:rPr>
-              <a:t>Component-specific policies for required names, roles, states, hierarchy, and keyboard behavior.</a:t>
-            </a:r>
-            <a:endParaRPr lang="en-US" sz="1150" dirty="0"/>
-          </a:p>
-        </p:txBody>
-      </p:sp>
-      <p:sp>
-        <p:nvSpPr>
-          <p:cNvPr id="26" name="Shape 24"/>
-          <p:cNvSpPr/>
-          <p:nvPr/>
-        </p:nvSpPr>
-        <p:spPr>
-          <a:xfrm>
-            <a:off x="8046720" y="3383280"/>
-            <a:ext cx="3474720" cy="1234440"/>
-          </a:xfrm>
-          <a:prstGeom prst="roundRect">
-            <a:avLst>
-              <a:gd name="adj" fmla="val 5926"/>
-            </a:avLst>
-          </a:prstGeom>
-          <a:solidFill>
-            <a:srgbClr val="F7F9FC"/>
-          </a:solidFill>
-          <a:ln w="12700">
-            <a:solidFill>
-              <a:srgbClr val="D9E2EC"/>
-            </a:solidFill>
-            <a:prstDash val="solid"/>
-          </a:ln>
-        </p:spPr>
-      </p:sp>
-      <p:sp>
-        <p:nvSpPr>
-          <p:cNvPr id="27" name="Shape 25"/>
-          <p:cNvSpPr/>
-          <p:nvPr/>
-        </p:nvSpPr>
-        <p:spPr>
-          <a:xfrm>
-            <a:off x="8046720" y="3383280"/>
-            <a:ext cx="73152" cy="1234440"/>
-          </a:xfrm>
-          <a:prstGeom prst="rect">
-            <a:avLst/>
-          </a:prstGeom>
-          <a:solidFill>
-            <a:srgbClr val="0078D4"/>
-          </a:solidFill>
-          <a:ln w="12700">
-            <a:solidFill>
-              <a:srgbClr val="0078D4"/>
-            </a:solidFill>
-            <a:prstDash val="solid"/>
-          </a:ln>
-        </p:spPr>
-      </p:sp>
-      <p:sp>
-        <p:nvSpPr>
-          <p:cNvPr id="28" name="Text 26"/>
-          <p:cNvSpPr/>
-          <p:nvPr/>
-        </p:nvSpPr>
-        <p:spPr>
-          <a:xfrm>
-            <a:off x="8275320" y="3547872"/>
-            <a:ext cx="3108960" cy="320040"/>
-          </a:xfrm>
-          <a:prstGeom prst="rect">
-            <a:avLst/>
-          </a:prstGeom>
-          <a:noFill/>
-          <a:ln/>
-        </p:spPr>
-        <p:txBody>
-          <a:bodyPr wrap="square" lIns="0" tIns="0" rIns="0" bIns="0" rtlCol="0" anchor="ctr"/>
-          <a:lstStyle/>
-          <a:p>
-            <a:pPr indent="0" marL="0">
-              <a:buNone/>
-            </a:pPr>
-            <a:r>
-              <a:rPr lang="en-US" sz="1600" b="1" dirty="0">
-                <a:solidFill>
-                  <a:srgbClr val="172033"/>
-                </a:solidFill>
-                <a:latin typeface="Segoe UI" pitchFamily="34" charset="0"/>
-                <a:ea typeface="Segoe UI" pitchFamily="34" charset="-122"/>
-                <a:cs typeface="Segoe UI" pitchFamily="34" charset="-120"/>
-              </a:rPr>
-              <a:t>Cross-build matrix</a:t>
-            </a:r>
-            <a:endParaRPr lang="en-US" sz="1600" dirty="0"/>
-          </a:p>
-        </p:txBody>
-      </p:sp>
-      <p:sp>
-        <p:nvSpPr>
-          <p:cNvPr id="29" name="Text 27"/>
-          <p:cNvSpPr/>
-          <p:nvPr/>
-        </p:nvSpPr>
-        <p:spPr>
-          <a:xfrm>
-            <a:off x="8275320" y="3950208"/>
-            <a:ext cx="3108960" cy="521208"/>
-          </a:xfrm>
-          <a:prstGeom prst="rect">
-            <a:avLst/>
-          </a:prstGeom>
-          <a:noFill/>
-          <a:ln/>
-        </p:spPr>
-        <p:txBody>
-          <a:bodyPr wrap="square" lIns="0" tIns="0" rIns="0" bIns="0" rtlCol="0" anchor="t"/>
-          <a:lstStyle/>
-          <a:p>
-            <a:pPr indent="0" marL="0">
-              <a:buNone/>
-            </a:pPr>
-            <a:r>
-              <a:rPr lang="en-US" sz="1150" dirty="0">
-                <a:solidFill>
-                  <a:srgbClr val="5E6A7D"/>
-                </a:solidFill>
-                <a:latin typeface="Segoe UI" pitchFamily="34" charset="0"/>
-                <a:ea typeface="Segoe UI" pitchFamily="34" charset="-122"/>
-                <a:cs typeface="Segoe UI" pitchFamily="34" charset="-120"/>
-              </a:rPr>
-              <a:t>Compare Fabric migrations, dependency upgrades, release branches, and Windows versions at scale.</a:t>
-            </a:r>
-            <a:endParaRPr lang="en-US" sz="1150" dirty="0"/>
-          </a:p>
-        </p:txBody>
-      </p:sp>
-      <p:sp>
-        <p:nvSpPr>
-          <p:cNvPr id="30" name="Text 28"/>
-          <p:cNvSpPr/>
-          <p:nvPr/>
-        </p:nvSpPr>
-        <p:spPr>
-          <a:xfrm>
-            <a:off x="1188720" y="5257800"/>
-            <a:ext cx="9784080" cy="530352"/>
-          </a:xfrm>
-          <a:prstGeom prst="rect">
-            <a:avLst/>
-          </a:prstGeom>
-          <a:noFill/>
-          <a:ln/>
-        </p:spPr>
-        <p:txBody>
-          <a:bodyPr wrap="square" lIns="0" tIns="0" rIns="0" bIns="0" rtlCol="0" anchor="ctr"/>
-          <a:lstStyle/>
-          <a:p>
-            <a:pPr algn="ctr" indent="0" marL="0">
-              <a:buNone/>
-            </a:pPr>
-            <a:r>
-              <a:rPr lang="en-US" sz="2000" b="1" dirty="0">
-                <a:solidFill>
-                  <a:srgbClr val="071A2B"/>
-                </a:solidFill>
-              </a:rPr>
-              <a:t>Next milestone: turn the local proof into a repeatable RNW CI scenario.</a:t>
-            </a:r>
-            <a:endParaRPr lang="en-US" sz="2000" dirty="0"/>
-          </a:p>
-        </p:txBody>
-      </p:sp>
-      <p:sp>
-        <p:nvSpPr>
-          <p:cNvPr id="31" name="Text 29"/>
-          <p:cNvSpPr/>
-          <p:nvPr/>
-        </p:nvSpPr>
-        <p:spPr>
-          <a:xfrm>
-            <a:off x="502920" y="6556248"/>
-            <a:ext cx="6400800" cy="164592"/>
-          </a:xfrm>
-          <a:prstGeom prst="rect">
-            <a:avLst/>
-          </a:prstGeom>
-          <a:noFill/>
-          <a:ln/>
-        </p:spPr>
-        <p:txBody>
-          <a:bodyPr wrap="square" lIns="0" tIns="0" rIns="0" bIns="0" rtlCol="0" anchor="ctr"/>
-          <a:lstStyle/>
-          <a:p>
-            <a:pPr indent="0" marL="0">
-              <a:buNone/>
-            </a:pPr>
-            <a:r>
-              <a:rPr lang="en-US" sz="800" dirty="0">
-                <a:solidFill>
-                  <a:srgbClr val="7C8798"/>
-                </a:solidFill>
-                <a:latin typeface="Segoe UI" pitchFamily="34" charset="0"/>
-                <a:ea typeface="Segoe UI" pitchFamily="34" charset="-122"/>
-                <a:cs typeface="Segoe UI" pitchFamily="34" charset="-120"/>
-              </a:rPr>
               <a:t>FHL 2026 · Accessibility Tree Snapshot &amp; Diff</a:t>
             </a:r>
             <a:endParaRPr lang="en-US" sz="800" dirty="0"/>
@@ -5305,7 +4915,7 @@
       </p:sp>
       <p:sp>
         <p:nvSpPr>
-          <p:cNvPr id="32" name="Text 30"/>
+          <p:cNvPr id="20" name="Text 18"/>
           <p:cNvSpPr/>
           <p:nvPr/>
         </p:nvSpPr>
@@ -8834,12 +8444,12 @@
         </p:nvSpPr>
         <p:spPr>
           <a:xfrm>
-            <a:off x="640080" y="1828800"/>
-            <a:ext cx="3474720" cy="1234440"/>
+            <a:off x="822960" y="1874520"/>
+            <a:ext cx="5166360" cy="1417320"/>
           </a:xfrm>
           <a:prstGeom prst="roundRect">
             <a:avLst>
-              <a:gd name="adj" fmla="val 5926"/>
+              <a:gd name="adj" fmla="val 5161"/>
             </a:avLst>
           </a:prstGeom>
           <a:solidFill>
@@ -8861,8 +8471,8 @@
         </p:nvSpPr>
         <p:spPr>
           <a:xfrm>
-            <a:off x="640080" y="1828800"/>
-            <a:ext cx="73152" cy="1234440"/>
+            <a:off x="822960" y="1874520"/>
+            <a:ext cx="73152" cy="1417320"/>
           </a:xfrm>
           <a:prstGeom prst="rect">
             <a:avLst/>
@@ -8886,8 +8496,8 @@
         </p:nvSpPr>
         <p:spPr>
           <a:xfrm>
-            <a:off x="868680" y="1993392"/>
-            <a:ext cx="3108960" cy="320040"/>
+            <a:off x="1051560" y="2039112"/>
+            <a:ext cx="4800600" cy="320040"/>
           </a:xfrm>
           <a:prstGeom prst="rect">
             <a:avLst/>
@@ -8911,7 +8521,7 @@
                 <a:ea typeface="Segoe UI" pitchFamily="34" charset="-122"/>
                 <a:cs typeface="Segoe UI" pitchFamily="34" charset="-120"/>
               </a:rPr>
-              <a:t>Bounded incremental capture</a:t>
+              <a:t>Safe on large applications</a:t>
             </a:r>
             <a:endParaRPr lang="en-US" sz="1600" dirty="0"/>
           </a:p>
@@ -8925,8 +8535,8 @@
         </p:nvSpPr>
         <p:spPr>
           <a:xfrm>
-            <a:off x="868680" y="2395728"/>
-            <a:ext cx="3108960" cy="521208"/>
+            <a:off x="1051560" y="2441448"/>
+            <a:ext cx="4800600" cy="704088"/>
           </a:xfrm>
           <a:prstGeom prst="rect">
             <a:avLst/>
@@ -8950,7 +8560,7 @@
                 <a:ea typeface="Segoe UI" pitchFamily="34" charset="-122"/>
                 <a:cs typeface="Segoe UI" pitchFamily="34" charset="-120"/>
               </a:rPr>
-              <a:t>TreeWalker traversal applies depth and node limits before requesting more descendants.</a:t>
+              <a:t>The tool stops at configured depth and element limits before requesting more of the accessibility tree.</a:t>
             </a:r>
             <a:endParaRPr lang="en-US" sz="1150" dirty="0"/>
           </a:p>
@@ -8964,12 +8574,12 @@
         </p:nvSpPr>
         <p:spPr>
           <a:xfrm>
-            <a:off x="4343400" y="1828800"/>
-            <a:ext cx="3474720" cy="1234440"/>
+            <a:off x="6217920" y="1874520"/>
+            <a:ext cx="5166360" cy="1417320"/>
           </a:xfrm>
           <a:prstGeom prst="roundRect">
             <a:avLst>
-              <a:gd name="adj" fmla="val 5926"/>
+              <a:gd name="adj" fmla="val 5161"/>
             </a:avLst>
           </a:prstGeom>
           <a:solidFill>
@@ -8991,8 +8601,8 @@
         </p:nvSpPr>
         <p:spPr>
           <a:xfrm>
-            <a:off x="4343400" y="1828800"/>
-            <a:ext cx="73152" cy="1234440"/>
+            <a:off x="6217920" y="1874520"/>
+            <a:ext cx="73152" cy="1417320"/>
           </a:xfrm>
           <a:prstGeom prst="rect">
             <a:avLst/>
@@ -9016,8 +8626,8 @@
         </p:nvSpPr>
         <p:spPr>
           <a:xfrm>
-            <a:off x="4572000" y="1993392"/>
-            <a:ext cx="3108960" cy="320040"/>
+            <a:off x="6446520" y="2039112"/>
+            <a:ext cx="4800600" cy="320040"/>
           </a:xfrm>
           <a:prstGeom prst="rect">
             <a:avLst/>
@@ -9041,7 +8651,7 @@
                 <a:ea typeface="Segoe UI" pitchFamily="34" charset="-122"/>
                 <a:cs typeface="Segoe UI" pitchFamily="34" charset="-120"/>
               </a:rPr>
-              <a:t>Stable sibling matching</a:t>
+              <a:t>Accurate, low-noise comparisons</a:t>
             </a:r>
             <a:endParaRPr lang="en-US" sz="1600" dirty="0"/>
           </a:p>
@@ -9055,8 +8665,8 @@
         </p:nvSpPr>
         <p:spPr>
           <a:xfrm>
-            <a:off x="4572000" y="2395728"/>
-            <a:ext cx="3108960" cy="521208"/>
+            <a:off x="6446520" y="2441448"/>
+            <a:ext cx="4800600" cy="704088"/>
           </a:xfrm>
           <a:prstGeom prst="rect">
             <a:avLst/>
@@ -9080,7 +8690,7 @@
                 <a:ea typeface="Segoe UI" pitchFamily="34" charset="-122"/>
                 <a:cs typeface="Segoe UI" pitchFamily="34" charset="-120"/>
               </a:rPr>
-              <a:t>Automation IDs, stable characteristics, and bounded sequence alignment prevent cascade noise.</a:t>
+              <a:t>Elements are matched within the same parent so one insertion does not make the rest of the page look different.</a:t>
             </a:r>
             <a:endParaRPr lang="en-US" sz="1150" dirty="0"/>
           </a:p>
@@ -9094,12 +8704,12 @@
         </p:nvSpPr>
         <p:spPr>
           <a:xfrm>
-            <a:off x="8046720" y="1828800"/>
-            <a:ext cx="3474720" cy="1234440"/>
+            <a:off x="822960" y="3611880"/>
+            <a:ext cx="5166360" cy="1417320"/>
           </a:xfrm>
           <a:prstGeom prst="roundRect">
             <a:avLst>
-              <a:gd name="adj" fmla="val 5926"/>
+              <a:gd name="adj" fmla="val 5161"/>
             </a:avLst>
           </a:prstGeom>
           <a:solidFill>
@@ -9121,8 +8731,8 @@
         </p:nvSpPr>
         <p:spPr>
           <a:xfrm>
-            <a:off x="8046720" y="1828800"/>
-            <a:ext cx="73152" cy="1234440"/>
+            <a:off x="822960" y="3611880"/>
+            <a:ext cx="73152" cy="1417320"/>
           </a:xfrm>
           <a:prstGeom prst="rect">
             <a:avLst/>
@@ -9146,8 +8756,8 @@
         </p:nvSpPr>
         <p:spPr>
           <a:xfrm>
-            <a:off x="8275320" y="1993392"/>
-            <a:ext cx="3108960" cy="320040"/>
+            <a:off x="1051560" y="3776472"/>
+            <a:ext cx="4800600" cy="320040"/>
           </a:xfrm>
           <a:prstGeom prst="rect">
             <a:avLst/>
@@ -9171,7 +8781,7 @@
                 <a:ea typeface="Segoe UI" pitchFamily="34" charset="-122"/>
                 <a:cs typeface="Segoe UI" pitchFamily="34" charset="-120"/>
               </a:rPr>
-              <a:t>Incomplete-capture safety</a:t>
+              <a:t>Never hides an incomplete scan</a:t>
             </a:r>
             <a:endParaRPr lang="en-US" sz="1600" dirty="0"/>
           </a:p>
@@ -9185,8 +8795,8 @@
         </p:nvSpPr>
         <p:spPr>
           <a:xfrm>
-            <a:off x="8275320" y="2395728"/>
-            <a:ext cx="3108960" cy="521208"/>
+            <a:off x="1051560" y="4178808"/>
+            <a:ext cx="4800600" cy="704088"/>
           </a:xfrm>
           <a:prstGeom prst="rect">
             <a:avLst/>
@@ -9210,7 +8820,7 @@
                 <a:ea typeface="Segoe UI" pitchFamily="34" charset="-122"/>
                 <a:cs typeface="Segoe UI" pitchFamily="34" charset="-120"/>
               </a:rPr>
-              <a:t>Transient UIA failures are retained as explicit incomplete snapshots instead of false clean results.</a:t>
+              <a:t>If an application changes or an element disappears during capture, the snapshot is marked incomplete—not reported as clean.</a:t>
             </a:r>
             <a:endParaRPr lang="en-US" sz="1150" dirty="0"/>
           </a:p>
@@ -9224,12 +8834,12 @@
         </p:nvSpPr>
         <p:spPr>
           <a:xfrm>
-            <a:off x="640080" y="3383280"/>
-            <a:ext cx="3474720" cy="1234440"/>
+            <a:off x="6217920" y="3611880"/>
+            <a:ext cx="5166360" cy="1417320"/>
           </a:xfrm>
           <a:prstGeom prst="roundRect">
             <a:avLst>
-              <a:gd name="adj" fmla="val 5926"/>
+              <a:gd name="adj" fmla="val 5161"/>
             </a:avLst>
           </a:prstGeom>
           <a:solidFill>
@@ -9251,8 +8861,8 @@
         </p:nvSpPr>
         <p:spPr>
           <a:xfrm>
-            <a:off x="640080" y="3383280"/>
-            <a:ext cx="73152" cy="1234440"/>
+            <a:off x="6217920" y="3611880"/>
+            <a:ext cx="73152" cy="1417320"/>
           </a:xfrm>
           <a:prstGeom prst="rect">
             <a:avLst/>
@@ -9276,8 +8886,8 @@
         </p:nvSpPr>
         <p:spPr>
           <a:xfrm>
-            <a:off x="868680" y="3547872"/>
-            <a:ext cx="3108960" cy="320040"/>
+            <a:off x="6446520" y="3776472"/>
+            <a:ext cx="4800600" cy="320040"/>
           </a:xfrm>
           <a:prstGeom prst="rect">
             <a:avLst/>
@@ -9301,7 +8911,7 @@
                 <a:ea typeface="Segoe UI" pitchFamily="34" charset="-122"/>
                 <a:cs typeface="Segoe UI" pitchFamily="34" charset="-120"/>
               </a:rPr>
-              <a:t>Privacy by design</a:t>
+              <a:t>Protects data and report output</a:t>
             </a:r>
             <a:endParaRPr lang="en-US" sz="1600" dirty="0"/>
           </a:p>
@@ -9315,8 +8925,8 @@
         </p:nvSpPr>
         <p:spPr>
           <a:xfrm>
-            <a:off x="868680" y="3950208"/>
-            <a:ext cx="3108960" cy="521208"/>
+            <a:off x="6446520" y="4178808"/>
+            <a:ext cx="4800600" cy="704088"/>
           </a:xfrm>
           <a:prstGeom prst="rect">
             <a:avLst/>
@@ -9340,7 +8950,7 @@
                 <a:ea typeface="Segoe UI" pitchFamily="34" charset="-122"/>
                 <a:cs typeface="Segoe UI" pitchFamily="34" charset="-120"/>
               </a:rPr>
-              <a:t>No text-field values, runtime IDs, exact bounds, or keyboard-focus state in comparisons.</a:t>
+              <a:t>Sensitive text values and volatile IDs are excluded, and application-controlled text is sanitized before display.</a:t>
             </a:r>
             <a:endParaRPr lang="en-US" sz="1150" dirty="0"/>
           </a:p>
@@ -9348,66 +8958,50 @@
       </p:sp>
       <p:sp>
         <p:nvSpPr>
-          <p:cNvPr id="22" name="Shape 20"/>
-          <p:cNvSpPr/>
-          <p:nvPr/>
-        </p:nvSpPr>
-        <p:spPr>
-          <a:xfrm>
-            <a:off x="4343400" y="3383280"/>
-            <a:ext cx="3474720" cy="1234440"/>
-          </a:xfrm>
-          <a:prstGeom prst="roundRect">
-            <a:avLst>
-              <a:gd name="adj" fmla="val 5926"/>
-            </a:avLst>
-          </a:prstGeom>
-          <a:solidFill>
-            <a:srgbClr val="F7F9FC"/>
-          </a:solidFill>
-          <a:ln w="12700">
-            <a:solidFill>
-              <a:srgbClr val="D9E2EC"/>
-            </a:solidFill>
-            <a:prstDash val="solid"/>
-          </a:ln>
-        </p:spPr>
-      </p:sp>
-      <p:sp>
-        <p:nvSpPr>
-          <p:cNvPr id="23" name="Shape 21"/>
-          <p:cNvSpPr/>
-          <p:nvPr/>
-        </p:nvSpPr>
-        <p:spPr>
-          <a:xfrm>
-            <a:off x="4343400" y="3383280"/>
-            <a:ext cx="73152" cy="1234440"/>
-          </a:xfrm>
-          <a:prstGeom prst="rect">
-            <a:avLst/>
-          </a:prstGeom>
-          <a:solidFill>
-            <a:srgbClr val="FFB900"/>
-          </a:solidFill>
-          <a:ln w="12700">
-            <a:solidFill>
-              <a:srgbClr val="FFB900"/>
-            </a:solidFill>
-            <a:prstDash val="solid"/>
-          </a:ln>
-        </p:spPr>
-      </p:sp>
-      <p:sp>
-        <p:nvSpPr>
-          <p:cNvPr id="24" name="Text 22"/>
-          <p:cNvSpPr/>
-          <p:nvPr/>
-        </p:nvSpPr>
-        <p:spPr>
-          <a:xfrm>
-            <a:off x="4572000" y="3547872"/>
-            <a:ext cx="3108960" cy="320040"/>
+          <p:cNvPr id="22" name="Text 20"/>
+          <p:cNvSpPr/>
+          <p:nvPr/>
+        </p:nvSpPr>
+        <p:spPr>
+          <a:xfrm>
+            <a:off x="1005840" y="5440680"/>
+            <a:ext cx="10149840" cy="566928"/>
+          </a:xfrm>
+          <a:prstGeom prst="rect">
+            <a:avLst/>
+          </a:prstGeom>
+          <a:noFill/>
+          <a:ln/>
+        </p:spPr>
+        <p:txBody>
+          <a:bodyPr wrap="square" lIns="0" tIns="0" rIns="0" bIns="0" rtlCol="0" anchor="ctr"/>
+          <a:lstStyle/>
+          <a:p>
+            <a:pPr algn="ctr" indent="0" marL="0">
+              <a:buNone/>
+            </a:pPr>
+            <a:r>
+              <a:rPr lang="en-US" sz="1900" b="1" dirty="0">
+                <a:solidFill>
+                  <a:srgbClr val="071A2B"/>
+                </a:solidFill>
+              </a:rPr>
+              <a:t>15 tests · warning-free Release build · live capture/diff verified · zero RNW runtime files changed</a:t>
+            </a:r>
+            <a:endParaRPr lang="en-US" sz="1900" dirty="0"/>
+          </a:p>
+        </p:txBody>
+      </p:sp>
+      <p:sp>
+        <p:nvSpPr>
+          <p:cNvPr id="23" name="Text 21"/>
+          <p:cNvSpPr/>
+          <p:nvPr/>
+        </p:nvSpPr>
+        <p:spPr>
+          <a:xfrm>
+            <a:off x="502920" y="6556248"/>
+            <a:ext cx="6400800" cy="164592"/>
           </a:xfrm>
           <a:prstGeom prst="rect">
             <a:avLst/>
@@ -9423,258 +9017,14 @@
               <a:buNone/>
             </a:pPr>
             <a:r>
-              <a:rPr lang="en-US" sz="1600" b="1" dirty="0">
-                <a:solidFill>
-                  <a:srgbClr val="172033"/>
+              <a:rPr lang="en-US" sz="800" dirty="0">
+                <a:solidFill>
+                  <a:srgbClr val="7C8798"/>
                 </a:solidFill>
                 <a:latin typeface="Segoe UI" pitchFamily="34" charset="0"/>
                 <a:ea typeface="Segoe UI" pitchFamily="34" charset="-122"/>
                 <a:cs typeface="Segoe UI" pitchFamily="34" charset="-120"/>
               </a:rPr>
-              <a:t>Deterministic schema</a:t>
-            </a:r>
-            <a:endParaRPr lang="en-US" sz="1600" dirty="0"/>
-          </a:p>
-        </p:txBody>
-      </p:sp>
-      <p:sp>
-        <p:nvSpPr>
-          <p:cNvPr id="25" name="Text 23"/>
-          <p:cNvSpPr/>
-          <p:nvPr/>
-        </p:nvSpPr>
-        <p:spPr>
-          <a:xfrm>
-            <a:off x="4572000" y="3950208"/>
-            <a:ext cx="3108960" cy="521208"/>
-          </a:xfrm>
-          <a:prstGeom prst="rect">
-            <a:avLst/>
-          </a:prstGeom>
-          <a:noFill/>
-          <a:ln/>
-        </p:spPr>
-        <p:txBody>
-          <a:bodyPr wrap="square" lIns="0" tIns="0" rIns="0" bIns="0" rtlCol="0" anchor="t"/>
-          <a:lstStyle/>
-          <a:p>
-            <a:pPr indent="0" marL="0">
-              <a:buNone/>
-            </a:pPr>
-            <a:r>
-              <a:rPr lang="en-US" sz="1150" dirty="0">
-                <a:solidFill>
-                  <a:srgbClr val="5E6A7D"/>
-                </a:solidFill>
-                <a:latin typeface="Segoe UI" pitchFamily="34" charset="0"/>
-                <a:ea typeface="Segoe UI" pitchFamily="34" charset="-122"/>
-                <a:cs typeface="Segoe UI" pitchFamily="34" charset="-120"/>
-              </a:rPr>
-              <a:t>Versioned JSON, complete validation, and stable ordering make results reviewable and testable.</a:t>
-            </a:r>
-            <a:endParaRPr lang="en-US" sz="1150" dirty="0"/>
-          </a:p>
-        </p:txBody>
-      </p:sp>
-      <p:sp>
-        <p:nvSpPr>
-          <p:cNvPr id="26" name="Shape 24"/>
-          <p:cNvSpPr/>
-          <p:nvPr/>
-        </p:nvSpPr>
-        <p:spPr>
-          <a:xfrm>
-            <a:off x="8046720" y="3383280"/>
-            <a:ext cx="3474720" cy="1234440"/>
-          </a:xfrm>
-          <a:prstGeom prst="roundRect">
-            <a:avLst>
-              <a:gd name="adj" fmla="val 5926"/>
-            </a:avLst>
-          </a:prstGeom>
-          <a:solidFill>
-            <a:srgbClr val="F7F9FC"/>
-          </a:solidFill>
-          <a:ln w="12700">
-            <a:solidFill>
-              <a:srgbClr val="D9E2EC"/>
-            </a:solidFill>
-            <a:prstDash val="solid"/>
-          </a:ln>
-        </p:spPr>
-      </p:sp>
-      <p:sp>
-        <p:nvSpPr>
-          <p:cNvPr id="27" name="Shape 25"/>
-          <p:cNvSpPr/>
-          <p:nvPr/>
-        </p:nvSpPr>
-        <p:spPr>
-          <a:xfrm>
-            <a:off x="8046720" y="3383280"/>
-            <a:ext cx="73152" cy="1234440"/>
-          </a:xfrm>
-          <a:prstGeom prst="rect">
-            <a:avLst/>
-          </a:prstGeom>
-          <a:solidFill>
-            <a:srgbClr val="0078D4"/>
-          </a:solidFill>
-          <a:ln w="12700">
-            <a:solidFill>
-              <a:srgbClr val="0078D4"/>
-            </a:solidFill>
-            <a:prstDash val="solid"/>
-          </a:ln>
-        </p:spPr>
-      </p:sp>
-      <p:sp>
-        <p:nvSpPr>
-          <p:cNvPr id="28" name="Text 26"/>
-          <p:cNvSpPr/>
-          <p:nvPr/>
-        </p:nvSpPr>
-        <p:spPr>
-          <a:xfrm>
-            <a:off x="8275320" y="3547872"/>
-            <a:ext cx="3108960" cy="320040"/>
-          </a:xfrm>
-          <a:prstGeom prst="rect">
-            <a:avLst/>
-          </a:prstGeom>
-          <a:noFill/>
-          <a:ln/>
-        </p:spPr>
-        <p:txBody>
-          <a:bodyPr wrap="square" lIns="0" tIns="0" rIns="0" bIns="0" rtlCol="0" anchor="ctr"/>
-          <a:lstStyle/>
-          <a:p>
-            <a:pPr indent="0" marL="0">
-              <a:buNone/>
-            </a:pPr>
-            <a:r>
-              <a:rPr lang="en-US" sz="1600" b="1" dirty="0">
-                <a:solidFill>
-                  <a:srgbClr val="172033"/>
-                </a:solidFill>
-                <a:latin typeface="Segoe UI" pitchFamily="34" charset="0"/>
-                <a:ea typeface="Segoe UI" pitchFamily="34" charset="-122"/>
-                <a:cs typeface="Segoe UI" pitchFamily="34" charset="-120"/>
-              </a:rPr>
-              <a:t>Hardened output</a:t>
-            </a:r>
-            <a:endParaRPr lang="en-US" sz="1600" dirty="0"/>
-          </a:p>
-        </p:txBody>
-      </p:sp>
-      <p:sp>
-        <p:nvSpPr>
-          <p:cNvPr id="29" name="Text 27"/>
-          <p:cNvSpPr/>
-          <p:nvPr/>
-        </p:nvSpPr>
-        <p:spPr>
-          <a:xfrm>
-            <a:off x="8275320" y="3950208"/>
-            <a:ext cx="3108960" cy="521208"/>
-          </a:xfrm>
-          <a:prstGeom prst="rect">
-            <a:avLst/>
-          </a:prstGeom>
-          <a:noFill/>
-          <a:ln/>
-        </p:spPr>
-        <p:txBody>
-          <a:bodyPr wrap="square" lIns="0" tIns="0" rIns="0" bIns="0" rtlCol="0" anchor="t"/>
-          <a:lstStyle/>
-          <a:p>
-            <a:pPr indent="0" marL="0">
-              <a:buNone/>
-            </a:pPr>
-            <a:r>
-              <a:rPr lang="en-US" sz="1150" dirty="0">
-                <a:solidFill>
-                  <a:srgbClr val="5E6A7D"/>
-                </a:solidFill>
-                <a:latin typeface="Segoe UI" pitchFamily="34" charset="0"/>
-                <a:ea typeface="Segoe UI" pitchFamily="34" charset="-122"/>
-                <a:cs typeface="Segoe UI" pitchFamily="34" charset="-120"/>
-              </a:rPr>
-              <a:t>Strict CLI enums and terminal-control sanitization protect console and Markdown reports.</a:t>
-            </a:r>
-            <a:endParaRPr lang="en-US" sz="1150" dirty="0"/>
-          </a:p>
-        </p:txBody>
-      </p:sp>
-      <p:sp>
-        <p:nvSpPr>
-          <p:cNvPr id="30" name="Text 28"/>
-          <p:cNvSpPr/>
-          <p:nvPr/>
-        </p:nvSpPr>
-        <p:spPr>
-          <a:xfrm>
-            <a:off x="1005840" y="5257800"/>
-            <a:ext cx="10149840" cy="566928"/>
-          </a:xfrm>
-          <a:prstGeom prst="rect">
-            <a:avLst/>
-          </a:prstGeom>
-          <a:noFill/>
-          <a:ln/>
-        </p:spPr>
-        <p:txBody>
-          <a:bodyPr wrap="square" lIns="0" tIns="0" rIns="0" bIns="0" rtlCol="0" anchor="ctr"/>
-          <a:lstStyle/>
-          <a:p>
-            <a:pPr algn="ctr" indent="0" marL="0">
-              <a:buNone/>
-            </a:pPr>
-            <a:r>
-              <a:rPr lang="en-US" sz="1900" b="1" dirty="0">
-                <a:solidFill>
-                  <a:srgbClr val="071A2B"/>
-                </a:solidFill>
-              </a:rPr>
-              <a:t>15 tests · warning-free Release build · live capture/diff verified · zero RNW runtime files changed</a:t>
-            </a:r>
-            <a:endParaRPr lang="en-US" sz="1900" dirty="0"/>
-          </a:p>
-        </p:txBody>
-      </p:sp>
-      <p:sp>
-        <p:nvSpPr>
-          <p:cNvPr id="31" name="Text 29"/>
-          <p:cNvSpPr/>
-          <p:nvPr/>
-        </p:nvSpPr>
-        <p:spPr>
-          <a:xfrm>
-            <a:off x="502920" y="6556248"/>
-            <a:ext cx="6400800" cy="164592"/>
-          </a:xfrm>
-          <a:prstGeom prst="rect">
-            <a:avLst/>
-          </a:prstGeom>
-          <a:noFill/>
-          <a:ln/>
-        </p:spPr>
-        <p:txBody>
-          <a:bodyPr wrap="square" lIns="0" tIns="0" rIns="0" bIns="0" rtlCol="0" anchor="ctr"/>
-          <a:lstStyle/>
-          <a:p>
-            <a:pPr indent="0" marL="0">
-              <a:buNone/>
-            </a:pPr>
-            <a:r>
-              <a:rPr lang="en-US" sz="800" dirty="0">
-                <a:solidFill>
-                  <a:srgbClr val="7C8798"/>
-                </a:solidFill>
-                <a:latin typeface="Segoe UI" pitchFamily="34" charset="0"/>
-                <a:ea typeface="Segoe UI" pitchFamily="34" charset="-122"/>
-                <a:cs typeface="Segoe UI" pitchFamily="34" charset="-120"/>
-              </a:rPr>
               <a:t>FHL 2026 · Accessibility Tree Snapshot &amp; Diff</a:t>
             </a:r>
             <a:endParaRPr lang="en-US" sz="800" dirty="0"/>
@@ -9683,7 +9033,7 @@
       </p:sp>
       <p:sp>
         <p:nvSpPr>
-          <p:cNvPr id="32" name="Text 30"/>
+          <p:cNvPr id="24" name="Text 22"/>
           <p:cNvSpPr/>
           <p:nvPr/>
         </p:nvSpPr>

</xml_diff>

<commit_message>
Improve FHL narration pacing and detail
Co-authored-by: Copilot <223556219+Copilot@users.noreply.github.com>

Copilot-Session: 0f63ea4f-a16b-4fa3-b141-785aec89b5e4
</commit_message>
<xml_diff>
--- a/FHL-Accessibility-Tree-Diff.pptx
+++ b/FHL-Accessibility-Tree-Diff.pptx
@@ -514,7 +514,7 @@
           <a:p>
             <a:r>
               <a:rPr lang="en-US" dirty="0"/>
-              <a:t>Hi everyone. Here's what we built during FHL: a tool that catches React Native Windows accessibility regressions you simply can't see in a screenshot.</a:t>
+              <a:t>Hi everyone. Here's what we built during FHL: a tool that catches React Native Windows accessibility regressions you simply can't see in a screenshot. Let me show you why that matters.</a:t>
             </a:r>
             <a:endParaRPr lang="en-US" dirty="0"/>
           </a:p>
@@ -602,7 +602,7 @@
           <a:p>
             <a:r>
               <a:rPr lang="en-US" dirty="0"/>
-              <a:t>The bigger win is timing. Instead of discovering accessibility problems at the end, engineers get clear evidence while the change is still in review.</a:t>
+              <a:t>The bigger win is timing. Instead of discovering accessibility problems near release, engineers get clear evidence while the change is still in review, when the fix is faster and safer.</a:t>
             </a:r>
             <a:endParaRPr lang="en-US" dirty="0"/>
           </a:p>
@@ -690,7 +690,7 @@
           <a:p>
             <a:r>
               <a:rPr lang="en-US" dirty="0"/>
-              <a:t>Once merged, the tool fits into the existing RNW workspace. The FHL branch and full documentation are already available for anyone who wants to try it.</a:t>
+              <a:t>Once merged, the tool fits into the existing RNW workspace, alongside other developer tooling. The FHL branch and full usage documentation are already available for anyone who wants to try it.</a:t>
             </a:r>
             <a:endParaRPr lang="en-US" dirty="0"/>
           </a:p>
@@ -778,7 +778,7 @@
           <a:p>
             <a:r>
               <a:rPr lang="en-US" dirty="0"/>
-              <a:t>From here, the top priorities are automatic pull-request checks, a keyboard focus recorder, and a visual explorer that makes reviewing diffs even easier.</a:t>
+              <a:t>From here, the top priorities are automatic pull-request checks, a recorder that explains keyboard focus movement, and a visual explorer that makes before-and-after differences easy to review.</a:t>
             </a:r>
             <a:endParaRPr lang="en-US" dirty="0"/>
           </a:p>
@@ -954,7 +954,7 @@
           <a:p>
             <a:r>
               <a:rPr lang="en-US" dirty="0"/>
-              <a:t>Take a look at these two Gallery builds. They appear identical. But on the right, Item 3 has quietly dropped out of keyboard navigation. That's the problem we're solving.</a:t>
+              <a:t>Take a look at these two Gallery builds. They appear identical. But on the right, Item 3 has quietly dropped out of keyboard navigation. A mouse user may never notice. A keyboard or screen reader user will.</a:t>
             </a:r>
             <a:endParaRPr lang="en-US" dirty="0"/>
           </a:p>
@@ -1042,7 +1042,7 @@
           <a:p>
             <a:r>
               <a:rPr lang="en-US" dirty="0"/>
-              <a:t>The idea is straightforward. Capture what assistive technology sees before a change, capture it again afterward, and highlight only the accessibility differences that deserve attention.</a:t>
+              <a:t>The idea is straightforward. Windows exposes a semantic accessibility tree: the names, roles, states, and focus behavior that assistive technology actually uses. We capture that tree before and after a change, then highlight the meaningful differences.</a:t>
             </a:r>
             <a:endParaRPr lang="en-US" dirty="0"/>
           </a:p>
@@ -1130,7 +1130,7 @@
           <a:p>
             <a:r>
               <a:rPr lang="en-US" dirty="0"/>
-              <a:t>For an engineer, it's just three steps: capture before, capture after, and compare. If the change looks risky, exit code one can stop the pull request.</a:t>
+              <a:t>For an engineer, it's three steps: capture before, capture after, and compare. The report explains exactly what changed. And if the change looks risky, exit code one can stop the pull request automatically.</a:t>
             </a:r>
             <a:endParaRPr lang="en-US" dirty="0"/>
           </a:p>
@@ -1218,7 +1218,7 @@
           <a:p>
             <a:r>
               <a:rPr lang="en-US" dirty="0"/>
-              <a:t>This really helps when pixels stay the same but semantics may shift—during Fabric migrations, native refactors, dependency upgrades, accessibility fixes, and release validation.</a:t>
+              <a:t>This is most useful when the pixels stay the same but the underlying semantics may shift—for example during Fabric migrations, native refactors, dependency upgrades, accessibility fixes, or release validation.</a:t>
             </a:r>
             <a:endParaRPr lang="en-US" dirty="0"/>
           </a:p>
@@ -1306,7 +1306,7 @@
           <a:p>
             <a:r>
               <a:rPr lang="en-US" dirty="0"/>
-              <a:t>We also worked hard to make the results trustworthy: scans are bounded, matching avoids noisy cascades, interrupted scans can't look clean, and sensitive application data stays out.</a:t>
+              <a:t>A noisy or unreliable diff wouldn't help, so we designed for trust. Scans are bounded, matching avoids a cascade of false changes, interrupted scans can never look clean, and sensitive application data stays out.</a:t>
             </a:r>
             <a:endParaRPr lang="en-US" dirty="0"/>
           </a:p>
@@ -1482,7 +1482,7 @@
           <a:p>
             <a:r>
               <a:rPr lang="en-US" dirty="0"/>
-              <a:t>And this is the result at a glance: same-looking screens, five real keyboard regressions, and a precise explanation of what changed.</a:t>
+              <a:t>And this is the result at a glance: same-looking screens, five real keyboard regressions, and a precise explanation of what changed. That's evidence a reviewer can act on immediately.</a:t>
             </a:r>
             <a:endParaRPr lang="en-US" dirty="0"/>
           </a:p>
@@ -1570,7 +1570,7 @@
           <a:p>
             <a:r>
               <a:rPr lang="en-US" dirty="0"/>
-              <a:t>This isn't just a concept. We finished the working tool, added fifteen tests, reached a warning-free build, and validated it against live Windows applications.</a:t>
+              <a:t>This isn't just a concept. We finished the working tool, added fifteen tests, reached a warning-free build, and validated it against live Windows applications—without changing RNW runtime behavior.</a:t>
             </a:r>
             <a:endParaRPr lang="en-US" dirty="0"/>
           </a:p>

</xml_diff>

<commit_message>
Add FHL presenter attribution
Co-authored-by: Copilot <223556219+Copilot@users.noreply.github.com>

Copilot-Session: 0f63ea4f-a16b-4fa3-b141-785aec89b5e4
</commit_message>
<xml_diff>
--- a/FHL-Accessibility-Tree-Diff.pptx
+++ b/FHL-Accessibility-Tree-Diff.pptx
@@ -2338,7 +2338,7 @@
         </p:nvSpPr>
         <p:spPr>
           <a:xfrm>
-            <a:off x="777240" y="5852160"/>
+            <a:off x="777240" y="5687568"/>
             <a:ext cx="8046720" cy="365760"/>
           </a:xfrm>
           <a:prstGeom prst="rect">
@@ -2366,6 +2366,45 @@
               <a:t>Built end-to-end during FHL: implementation, tests, hardening, live validation, and demo.</a:t>
             </a:r>
             <a:endParaRPr lang="en-US" sz="1300" dirty="0"/>
+          </a:p>
+        </p:txBody>
+      </p:sp>
+      <p:sp>
+        <p:nvSpPr>
+          <p:cNvPr id="10" name="Text 8"/>
+          <p:cNvSpPr/>
+          <p:nvPr/>
+        </p:nvSpPr>
+        <p:spPr>
+          <a:xfrm>
+            <a:off x="777240" y="6172200"/>
+            <a:ext cx="6217920" cy="292608"/>
+          </a:xfrm>
+          <a:prstGeom prst="rect">
+            <a:avLst/>
+          </a:prstGeom>
+          <a:noFill/>
+          <a:ln/>
+        </p:spPr>
+        <p:txBody>
+          <a:bodyPr wrap="square" lIns="0" tIns="0" rIns="0" bIns="0" rtlCol="0" anchor="ctr"/>
+          <a:lstStyle/>
+          <a:p>
+            <a:pPr indent="0" marL="0">
+              <a:buNone/>
+            </a:pPr>
+            <a:r>
+              <a:rPr lang="en-US" sz="1600" b="1" dirty="0">
+                <a:solidFill>
+                  <a:srgbClr val="FFFFFF"/>
+                </a:solidFill>
+                <a:latin typeface="Segoe UI" pitchFamily="34" charset="0"/>
+                <a:ea typeface="Segoe UI" pitchFamily="34" charset="-122"/>
+                <a:cs typeface="Segoe UI" pitchFamily="34" charset="-120"/>
+              </a:rPr>
+              <a:t>Presented by Anukrati Agrawal + AI</a:t>
+            </a:r>
+            <a:endParaRPr lang="en-US" sz="1600" dirty="0"/>
           </a:p>
         </p:txBody>
       </p:sp>

</xml_diff>

<commit_message>
Make FHL presenter attribution subtle
Co-authored-by: Copilot <223556219+Copilot@users.noreply.github.com>

Copilot-Session: 0f63ea4f-a16b-4fa3-b141-785aec89b5e4
</commit_message>
<xml_diff>
--- a/FHL-Accessibility-Tree-Diff.pptx
+++ b/FHL-Accessibility-Tree-Diff.pptx
@@ -2378,7 +2378,7 @@
         <p:spPr>
           <a:xfrm>
             <a:off x="777240" y="6172200"/>
-            <a:ext cx="6217920" cy="292608"/>
+            <a:ext cx="6217920" cy="219456"/>
           </a:xfrm>
           <a:prstGeom prst="rect">
             <a:avLst/>
@@ -2394,9 +2394,9 @@
               <a:buNone/>
             </a:pPr>
             <a:r>
-              <a:rPr lang="en-US" sz="1600" b="1" dirty="0">
-                <a:solidFill>
-                  <a:srgbClr val="FFFFFF"/>
+              <a:rPr lang="en-US" sz="1000" dirty="0">
+                <a:solidFill>
+                  <a:srgbClr val="A8BDD0"/>
                 </a:solidFill>
                 <a:latin typeface="Segoe UI" pitchFamily="34" charset="0"/>
                 <a:ea typeface="Segoe UI" pitchFamily="34" charset="-122"/>
@@ -2404,7 +2404,7 @@
               </a:rPr>
               <a:t>Presented by Anukrati Agrawal + AI</a:t>
             </a:r>
-            <a:endParaRPr lang="en-US" sz="1600" dirty="0"/>
+            <a:endParaRPr lang="en-US" sz="1000" dirty="0"/>
           </a:p>
         </p:txBody>
       </p:sp>

</xml_diff>